<commit_message>
fix(internship-3): use first-person labels on Branch Visits slide
Co-Authored-By: Claude Sonnet 5 <noreply@anthropic.com>
</commit_message>
<xml_diff>
--- a/306 - Internship 3/Internship 3 v2.pptx
+++ b/306 - Internship 3/Internship 3 v2.pptx
@@ -13229,7 +13229,7 @@
                 <a:cs typeface="Cormorant Garamond Bold"/>
                 <a:sym typeface="Cormorant Garamond Bold"/>
               </a:rPr>
-              <a:t>What We Did</a:t>
+              <a:t>What I Did</a:t>
             </a:r>
           </a:p>
         </p:txBody>
@@ -13270,7 +13270,7 @@
                 <a:cs typeface="Cormorant Garamond Bold"/>
                 <a:sym typeface="Cormorant Garamond Bold"/>
               </a:rPr>
-              <a:t>What We Found</a:t>
+              <a:t>What I Found</a:t>
             </a:r>
           </a:p>
         </p:txBody>

</xml_diff>

<commit_message>
fix(internship-3): remove leftover template logo/branding marks
Removed the generic ring icon, wave squiggle mark, and empty
'Core Solutions' label box from all 13 slides. Reviewed remaining
wording - no other first/third-person mismatches found.

Co-Authored-By: Claude Sonnet 5 <noreply@anthropic.com>
</commit_message>
<xml_diff>
--- a/306 - Internship 3/Internship 3 v2.pptx
+++ b/306 - Internship 3/Internship 3 v2.pptx
@@ -3455,118 +3455,6 @@
       </p:sp>
       <p:sp>
         <p:nvSpPr>
-          <p:cNvPr name="Freeform 10" id="10"/>
-          <p:cNvSpPr/>
-          <p:nvPr/>
-        </p:nvSpPr>
-        <p:spPr>
-          <a:xfrm flipH="false" flipV="false" rot="0">
-            <a:off x="9495251" y="7312613"/>
-            <a:ext cx="1447564" cy="628188"/>
-          </a:xfrm>
-          <a:custGeom>
-            <a:avLst/>
-            <a:gdLst/>
-            <a:ahLst/>
-            <a:cxnLst/>
-            <a:rect r="r" b="b" t="t" l="l"/>
-            <a:pathLst>
-              <a:path h="628188" w="1447564">
-                <a:moveTo>
-                  <a:pt x="0" y="0"/>
-                </a:moveTo>
-                <a:lnTo>
-                  <a:pt x="1447564" y="0"/>
-                </a:lnTo>
-                <a:lnTo>
-                  <a:pt x="1447564" y="628188"/>
-                </a:lnTo>
-                <a:lnTo>
-                  <a:pt x="0" y="628188"/>
-                </a:lnTo>
-                <a:lnTo>
-                  <a:pt x="0" y="0"/>
-                </a:lnTo>
-                <a:close/>
-              </a:path>
-            </a:pathLst>
-          </a:custGeom>
-          <a:blipFill>
-            <a:blip r:embed="rId8">
-              <a:extLst>
-                <a:ext uri="{96DAC541-7B7A-43D3-8B79-37D633B846F1}">
-                  <asvg:svgBlip xmlns:asvg="http://schemas.microsoft.com/office/drawing/2016/SVG/main" r:embed="rId9"/>
-                </a:ext>
-              </a:extLst>
-            </a:blip>
-            <a:stretch>
-              <a:fillRect l="0" t="0" r="0" b="0"/>
-            </a:stretch>
-          </a:blipFill>
-        </p:spPr>
-        <p:txBody>
-          <a:bodyPr/>
-          <a:p/>
-        </p:txBody>
-      </p:sp>
-      <p:sp>
-        <p:nvSpPr>
-          <p:cNvPr name="Freeform 11" id="11"/>
-          <p:cNvSpPr/>
-          <p:nvPr/>
-        </p:nvSpPr>
-        <p:spPr>
-          <a:xfrm flipH="false" flipV="false" rot="0">
-            <a:off x="1032684" y="1037874"/>
-            <a:ext cx="432986" cy="585638"/>
-          </a:xfrm>
-          <a:custGeom>
-            <a:avLst/>
-            <a:gdLst/>
-            <a:ahLst/>
-            <a:cxnLst/>
-            <a:rect r="r" b="b" t="t" l="l"/>
-            <a:pathLst>
-              <a:path h="585638" w="432986">
-                <a:moveTo>
-                  <a:pt x="0" y="0"/>
-                </a:moveTo>
-                <a:lnTo>
-                  <a:pt x="432987" y="0"/>
-                </a:lnTo>
-                <a:lnTo>
-                  <a:pt x="432987" y="585638"/>
-                </a:lnTo>
-                <a:lnTo>
-                  <a:pt x="0" y="585638"/>
-                </a:lnTo>
-                <a:lnTo>
-                  <a:pt x="0" y="0"/>
-                </a:lnTo>
-                <a:close/>
-              </a:path>
-            </a:pathLst>
-          </a:custGeom>
-          <a:blipFill>
-            <a:blip r:embed="rId10">
-              <a:extLst>
-                <a:ext uri="{96DAC541-7B7A-43D3-8B79-37D633B846F1}">
-                  <asvg:svgBlip xmlns:asvg="http://schemas.microsoft.com/office/drawing/2016/SVG/main" r:embed="rId11"/>
-                </a:ext>
-              </a:extLst>
-            </a:blip>
-            <a:stretch>
-              <a:fillRect l="0" t="0" r="-21157" b="-4158"/>
-            </a:stretch>
-          </a:blipFill>
-        </p:spPr>
-        <p:txBody>
-          <a:bodyPr/>
-          <a:p/>
-        </p:txBody>
-      </p:sp>
-      <p:sp>
-        <p:nvSpPr>
           <p:cNvPr name="TextBox 12" id="12"/>
           <p:cNvSpPr txBox="true"/>
           <p:nvPr/>
@@ -3657,103 +3545,6 @@
               <a:t>PRESENTATION</a:t>
             </a:r>
           </a:p>
-        </p:txBody>
-      </p:sp>
-      <p:sp>
-        <p:nvSpPr>
-          <p:cNvPr name="TextBox 14" id="14"/>
-          <p:cNvSpPr txBox="true"/>
-          <p:nvPr/>
-        </p:nvSpPr>
-        <p:spPr>
-          <a:xfrm rot="0">
-            <a:off x="1268082" y="1198060"/>
-            <a:ext cx="1535820" cy="266699"/>
-          </a:xfrm>
-          <a:prstGeom prst="rect">
-            <a:avLst/>
-          </a:prstGeom>
-        </p:spPr>
-        <p:txBody>
-          <a:bodyPr anchor="t" rtlCol="false" tIns="0" lIns="0" bIns="0" rIns="0">
-            <a:spAutoFit/>
-          </a:bodyPr>
-          <a:lstStyle/>
-          <a:p>
-            <a:pPr algn="l">
-              <a:lnSpc>
-                <a:spcPts val="2100"/>
-              </a:lnSpc>
-            </a:pPr>
-            <a:r>
-              <a:rPr lang="en-US" sz="1500" b="true">
-                <a:solidFill>
-                  <a:srgbClr val="042147"/>
-                </a:solidFill>
-                <a:latin typeface="Cormorant Garamond Bold"/>
-                <a:ea typeface="Cormorant Garamond Bold"/>
-                <a:cs typeface="Cormorant Garamond Bold"/>
-                <a:sym typeface="Cormorant Garamond Bold"/>
-              </a:rPr>
-              <a:t/>
-            </a:r>
-          </a:p>
-        </p:txBody>
-      </p:sp>
-      <p:sp>
-        <p:nvSpPr>
-          <p:cNvPr name="Freeform 15" id="15"/>
-          <p:cNvSpPr/>
-          <p:nvPr/>
-        </p:nvSpPr>
-        <p:spPr>
-          <a:xfrm flipH="false" flipV="false" rot="0">
-            <a:off x="1032684" y="1050223"/>
-            <a:ext cx="474326" cy="588321"/>
-          </a:xfrm>
-          <a:custGeom>
-            <a:avLst/>
-            <a:gdLst/>
-            <a:ahLst/>
-            <a:cxnLst/>
-            <a:rect r="r" b="b" t="t" l="l"/>
-            <a:pathLst>
-              <a:path h="588321" w="474326">
-                <a:moveTo>
-                  <a:pt x="0" y="0"/>
-                </a:moveTo>
-                <a:lnTo>
-                  <a:pt x="474326" y="0"/>
-                </a:lnTo>
-                <a:lnTo>
-                  <a:pt x="474326" y="588322"/>
-                </a:lnTo>
-                <a:lnTo>
-                  <a:pt x="0" y="588322"/>
-                </a:lnTo>
-                <a:lnTo>
-                  <a:pt x="0" y="0"/>
-                </a:lnTo>
-                <a:close/>
-              </a:path>
-            </a:pathLst>
-          </a:custGeom>
-          <a:blipFill>
-            <a:blip r:embed="rId10">
-              <a:extLst>
-                <a:ext uri="{96DAC541-7B7A-43D3-8B79-37D633B846F1}">
-                  <asvg:svgBlip xmlns:asvg="http://schemas.microsoft.com/office/drawing/2016/SVG/main" r:embed="rId11"/>
-                </a:ext>
-              </a:extLst>
-            </a:blip>
-            <a:stretch>
-              <a:fillRect l="0" t="-2099" r="-10598" b="-1584"/>
-            </a:stretch>
-          </a:blipFill>
-        </p:spPr>
-        <p:txBody>
-          <a:bodyPr/>
-          <a:p/>
         </p:txBody>
       </p:sp>
       <p:sp>
@@ -4014,62 +3805,6 @@
       </p:sp>
       <p:sp>
         <p:nvSpPr>
-          <p:cNvPr name="Freeform 5" id="5"/>
-          <p:cNvSpPr/>
-          <p:nvPr/>
-        </p:nvSpPr>
-        <p:spPr>
-          <a:xfrm flipH="false" flipV="false" rot="-5400000">
-            <a:off x="308903" y="5851351"/>
-            <a:ext cx="1447564" cy="628188"/>
-          </a:xfrm>
-          <a:custGeom>
-            <a:avLst/>
-            <a:gdLst/>
-            <a:ahLst/>
-            <a:cxnLst/>
-            <a:rect r="r" b="b" t="t" l="l"/>
-            <a:pathLst>
-              <a:path h="628188" w="1447564">
-                <a:moveTo>
-                  <a:pt x="0" y="0"/>
-                </a:moveTo>
-                <a:lnTo>
-                  <a:pt x="1447563" y="0"/>
-                </a:lnTo>
-                <a:lnTo>
-                  <a:pt x="1447563" y="628189"/>
-                </a:lnTo>
-                <a:lnTo>
-                  <a:pt x="0" y="628189"/>
-                </a:lnTo>
-                <a:lnTo>
-                  <a:pt x="0" y="0"/>
-                </a:lnTo>
-                <a:close/>
-              </a:path>
-            </a:pathLst>
-          </a:custGeom>
-          <a:blipFill>
-            <a:blip r:embed="rId4">
-              <a:extLst>
-                <a:ext uri="{96DAC541-7B7A-43D3-8B79-37D633B846F1}">
-                  <asvg:svgBlip xmlns:asvg="http://schemas.microsoft.com/office/drawing/2016/SVG/main" r:embed="rId5"/>
-                </a:ext>
-              </a:extLst>
-            </a:blip>
-            <a:stretch>
-              <a:fillRect l="0" t="0" r="0" b="0"/>
-            </a:stretch>
-          </a:blipFill>
-        </p:spPr>
-        <p:txBody>
-          <a:bodyPr/>
-          <a:p/>
-        </p:txBody>
-      </p:sp>
-      <p:sp>
-        <p:nvSpPr>
           <p:cNvPr name="TextBox 6" id="6"/>
           <p:cNvSpPr txBox="true"/>
           <p:nvPr/>
@@ -4285,159 +4020,6 @@
         <p:txBody>
           <a:bodyPr/>
           <a:p/>
-        </p:txBody>
-      </p:sp>
-      <p:sp>
-        <p:nvSpPr>
-          <p:cNvPr name="Freeform 9" id="9"/>
-          <p:cNvSpPr/>
-          <p:nvPr/>
-        </p:nvSpPr>
-        <p:spPr>
-          <a:xfrm flipH="false" flipV="false" rot="0">
-            <a:off x="1032684" y="1037874"/>
-            <a:ext cx="432986" cy="585638"/>
-          </a:xfrm>
-          <a:custGeom>
-            <a:avLst/>
-            <a:gdLst/>
-            <a:ahLst/>
-            <a:cxnLst/>
-            <a:rect r="r" b="b" t="t" l="l"/>
-            <a:pathLst>
-              <a:path h="585638" w="432986">
-                <a:moveTo>
-                  <a:pt x="0" y="0"/>
-                </a:moveTo>
-                <a:lnTo>
-                  <a:pt x="432987" y="0"/>
-                </a:lnTo>
-                <a:lnTo>
-                  <a:pt x="432987" y="585638"/>
-                </a:lnTo>
-                <a:lnTo>
-                  <a:pt x="0" y="585638"/>
-                </a:lnTo>
-                <a:lnTo>
-                  <a:pt x="0" y="0"/>
-                </a:lnTo>
-                <a:close/>
-              </a:path>
-            </a:pathLst>
-          </a:custGeom>
-          <a:blipFill>
-            <a:blip r:embed="rId10">
-              <a:extLst>
-                <a:ext uri="{96DAC541-7B7A-43D3-8B79-37D633B846F1}">
-                  <asvg:svgBlip xmlns:asvg="http://schemas.microsoft.com/office/drawing/2016/SVG/main" r:embed="rId11"/>
-                </a:ext>
-              </a:extLst>
-            </a:blip>
-            <a:stretch>
-              <a:fillRect l="0" t="0" r="-21157" b="-4158"/>
-            </a:stretch>
-          </a:blipFill>
-        </p:spPr>
-        <p:txBody>
-          <a:bodyPr/>
-          <a:p/>
-        </p:txBody>
-      </p:sp>
-      <p:sp>
-        <p:nvSpPr>
-          <p:cNvPr name="Freeform 10" id="10"/>
-          <p:cNvSpPr/>
-          <p:nvPr/>
-        </p:nvSpPr>
-        <p:spPr>
-          <a:xfrm flipH="false" flipV="false" rot="0">
-            <a:off x="1032684" y="1050223"/>
-            <a:ext cx="474326" cy="588321"/>
-          </a:xfrm>
-          <a:custGeom>
-            <a:avLst/>
-            <a:gdLst/>
-            <a:ahLst/>
-            <a:cxnLst/>
-            <a:rect r="r" b="b" t="t" l="l"/>
-            <a:pathLst>
-              <a:path h="588321" w="474326">
-                <a:moveTo>
-                  <a:pt x="0" y="0"/>
-                </a:moveTo>
-                <a:lnTo>
-                  <a:pt x="474326" y="0"/>
-                </a:lnTo>
-                <a:lnTo>
-                  <a:pt x="474326" y="588322"/>
-                </a:lnTo>
-                <a:lnTo>
-                  <a:pt x="0" y="588322"/>
-                </a:lnTo>
-                <a:lnTo>
-                  <a:pt x="0" y="0"/>
-                </a:lnTo>
-                <a:close/>
-              </a:path>
-            </a:pathLst>
-          </a:custGeom>
-          <a:blipFill>
-            <a:blip r:embed="rId10">
-              <a:extLst>
-                <a:ext uri="{96DAC541-7B7A-43D3-8B79-37D633B846F1}">
-                  <asvg:svgBlip xmlns:asvg="http://schemas.microsoft.com/office/drawing/2016/SVG/main" r:embed="rId11"/>
-                </a:ext>
-              </a:extLst>
-            </a:blip>
-            <a:stretch>
-              <a:fillRect l="0" t="-2099" r="-10598" b="-1584"/>
-            </a:stretch>
-          </a:blipFill>
-        </p:spPr>
-        <p:txBody>
-          <a:bodyPr/>
-          <a:p/>
-        </p:txBody>
-      </p:sp>
-      <p:sp>
-        <p:nvSpPr>
-          <p:cNvPr name="TextBox 11" id="11"/>
-          <p:cNvSpPr txBox="true"/>
-          <p:nvPr/>
-        </p:nvSpPr>
-        <p:spPr>
-          <a:xfrm rot="0">
-            <a:off x="1268082" y="1198060"/>
-            <a:ext cx="1535820" cy="266699"/>
-          </a:xfrm>
-          <a:prstGeom prst="rect">
-            <a:avLst/>
-          </a:prstGeom>
-        </p:spPr>
-        <p:txBody>
-          <a:bodyPr anchor="t" rtlCol="false" tIns="0" lIns="0" bIns="0" rIns="0">
-            <a:spAutoFit/>
-          </a:bodyPr>
-          <a:lstStyle/>
-          <a:p>
-            <a:pPr algn="l">
-              <a:lnSpc>
-                <a:spcPts val="2100"/>
-              </a:lnSpc>
-            </a:pPr>
-            <a:r>
-              <a:rPr lang="en-US" sz="1500" b="true">
-                <a:solidFill>
-                  <a:srgbClr val="042147"/>
-                </a:solidFill>
-                <a:latin typeface="Cormorant Garamond Bold"/>
-                <a:ea typeface="Cormorant Garamond Bold"/>
-                <a:cs typeface="Cormorant Garamond Bold"/>
-                <a:sym typeface="Cormorant Garamond Bold"/>
-              </a:rPr>
-              <a:t/>
-            </a:r>
-          </a:p>
         </p:txBody>
       </p:sp>
       <p:grpSp>
@@ -4791,62 +4373,6 @@
       </p:sp>
       <p:sp>
         <p:nvSpPr>
-          <p:cNvPr name="Freeform 5" id="5"/>
-          <p:cNvSpPr/>
-          <p:nvPr/>
-        </p:nvSpPr>
-        <p:spPr>
-          <a:xfrm flipH="false" flipV="false" rot="-5400000">
-            <a:off x="16535518" y="5781697"/>
-            <a:ext cx="1447564" cy="628188"/>
-          </a:xfrm>
-          <a:custGeom>
-            <a:avLst/>
-            <a:gdLst/>
-            <a:ahLst/>
-            <a:cxnLst/>
-            <a:rect r="r" b="b" t="t" l="l"/>
-            <a:pathLst>
-              <a:path h="628188" w="1447564">
-                <a:moveTo>
-                  <a:pt x="0" y="0"/>
-                </a:moveTo>
-                <a:lnTo>
-                  <a:pt x="1447564" y="0"/>
-                </a:lnTo>
-                <a:lnTo>
-                  <a:pt x="1447564" y="628188"/>
-                </a:lnTo>
-                <a:lnTo>
-                  <a:pt x="0" y="628188"/>
-                </a:lnTo>
-                <a:lnTo>
-                  <a:pt x="0" y="0"/>
-                </a:lnTo>
-                <a:close/>
-              </a:path>
-            </a:pathLst>
-          </a:custGeom>
-          <a:blipFill>
-            <a:blip r:embed="rId6">
-              <a:extLst>
-                <a:ext uri="{96DAC541-7B7A-43D3-8B79-37D633B846F1}">
-                  <asvg:svgBlip xmlns:asvg="http://schemas.microsoft.com/office/drawing/2016/SVG/main" r:embed="rId7"/>
-                </a:ext>
-              </a:extLst>
-            </a:blip>
-            <a:stretch>
-              <a:fillRect l="0" t="0" r="0" b="0"/>
-            </a:stretch>
-          </a:blipFill>
-        </p:spPr>
-        <p:txBody>
-          <a:bodyPr/>
-          <a:p/>
-        </p:txBody>
-      </p:sp>
-      <p:sp>
-        <p:nvSpPr>
           <p:cNvPr name="Freeform 6" id="6"/>
           <p:cNvSpPr/>
           <p:nvPr/>
@@ -4894,159 +4420,6 @@
             </a:blip>
             <a:stretch>
               <a:fillRect l="0" t="0" r="0" b="0"/>
-            </a:stretch>
-          </a:blipFill>
-        </p:spPr>
-        <p:txBody>
-          <a:bodyPr/>
-          <a:p/>
-        </p:txBody>
-      </p:sp>
-      <p:sp>
-        <p:nvSpPr>
-          <p:cNvPr name="Freeform 7" id="7"/>
-          <p:cNvSpPr/>
-          <p:nvPr/>
-        </p:nvSpPr>
-        <p:spPr>
-          <a:xfrm flipH="false" flipV="false" rot="0">
-            <a:off x="1032684" y="1037874"/>
-            <a:ext cx="432986" cy="585638"/>
-          </a:xfrm>
-          <a:custGeom>
-            <a:avLst/>
-            <a:gdLst/>
-            <a:ahLst/>
-            <a:cxnLst/>
-            <a:rect r="r" b="b" t="t" l="l"/>
-            <a:pathLst>
-              <a:path h="585638" w="432986">
-                <a:moveTo>
-                  <a:pt x="0" y="0"/>
-                </a:moveTo>
-                <a:lnTo>
-                  <a:pt x="432987" y="0"/>
-                </a:lnTo>
-                <a:lnTo>
-                  <a:pt x="432987" y="585638"/>
-                </a:lnTo>
-                <a:lnTo>
-                  <a:pt x="0" y="585638"/>
-                </a:lnTo>
-                <a:lnTo>
-                  <a:pt x="0" y="0"/>
-                </a:lnTo>
-                <a:close/>
-              </a:path>
-            </a:pathLst>
-          </a:custGeom>
-          <a:blipFill>
-            <a:blip r:embed="rId8">
-              <a:extLst>
-                <a:ext uri="{96DAC541-7B7A-43D3-8B79-37D633B846F1}">
-                  <asvg:svgBlip xmlns:asvg="http://schemas.microsoft.com/office/drawing/2016/SVG/main" r:embed="rId9"/>
-                </a:ext>
-              </a:extLst>
-            </a:blip>
-            <a:stretch>
-              <a:fillRect l="0" t="0" r="-21157" b="-4158"/>
-            </a:stretch>
-          </a:blipFill>
-        </p:spPr>
-        <p:txBody>
-          <a:bodyPr/>
-          <a:p/>
-        </p:txBody>
-      </p:sp>
-      <p:sp>
-        <p:nvSpPr>
-          <p:cNvPr name="TextBox 8" id="8"/>
-          <p:cNvSpPr txBox="true"/>
-          <p:nvPr/>
-        </p:nvSpPr>
-        <p:spPr>
-          <a:xfrm rot="0">
-            <a:off x="1268082" y="1198060"/>
-            <a:ext cx="1535820" cy="266699"/>
-          </a:xfrm>
-          <a:prstGeom prst="rect">
-            <a:avLst/>
-          </a:prstGeom>
-        </p:spPr>
-        <p:txBody>
-          <a:bodyPr anchor="t" rtlCol="false" tIns="0" lIns="0" bIns="0" rIns="0">
-            <a:spAutoFit/>
-          </a:bodyPr>
-          <a:lstStyle/>
-          <a:p>
-            <a:pPr algn="l">
-              <a:lnSpc>
-                <a:spcPts val="2100"/>
-              </a:lnSpc>
-            </a:pPr>
-            <a:r>
-              <a:rPr lang="en-US" sz="1500" b="true">
-                <a:solidFill>
-                  <a:srgbClr val="042147"/>
-                </a:solidFill>
-                <a:latin typeface="Cormorant Garamond Bold"/>
-                <a:ea typeface="Cormorant Garamond Bold"/>
-                <a:cs typeface="Cormorant Garamond Bold"/>
-                <a:sym typeface="Cormorant Garamond Bold"/>
-              </a:rPr>
-              <a:t/>
-            </a:r>
-          </a:p>
-        </p:txBody>
-      </p:sp>
-      <p:sp>
-        <p:nvSpPr>
-          <p:cNvPr name="Freeform 9" id="9"/>
-          <p:cNvSpPr/>
-          <p:nvPr/>
-        </p:nvSpPr>
-        <p:spPr>
-          <a:xfrm flipH="false" flipV="false" rot="0">
-            <a:off x="1032684" y="1050223"/>
-            <a:ext cx="474326" cy="588321"/>
-          </a:xfrm>
-          <a:custGeom>
-            <a:avLst/>
-            <a:gdLst/>
-            <a:ahLst/>
-            <a:cxnLst/>
-            <a:rect r="r" b="b" t="t" l="l"/>
-            <a:pathLst>
-              <a:path h="588321" w="474326">
-                <a:moveTo>
-                  <a:pt x="0" y="0"/>
-                </a:moveTo>
-                <a:lnTo>
-                  <a:pt x="474326" y="0"/>
-                </a:lnTo>
-                <a:lnTo>
-                  <a:pt x="474326" y="588322"/>
-                </a:lnTo>
-                <a:lnTo>
-                  <a:pt x="0" y="588322"/>
-                </a:lnTo>
-                <a:lnTo>
-                  <a:pt x="0" y="0"/>
-                </a:lnTo>
-                <a:close/>
-              </a:path>
-            </a:pathLst>
-          </a:custGeom>
-          <a:blipFill>
-            <a:blip r:embed="rId8">
-              <a:extLst>
-                <a:ext uri="{96DAC541-7B7A-43D3-8B79-37D633B846F1}">
-                  <asvg:svgBlip xmlns:asvg="http://schemas.microsoft.com/office/drawing/2016/SVG/main" r:embed="rId9"/>
-                </a:ext>
-              </a:extLst>
-            </a:blip>
-            <a:stretch>
-              <a:fillRect l="0" t="-2099" r="-10598" b="-1584"/>
             </a:stretch>
           </a:blipFill>
         </p:spPr>
@@ -5784,159 +5157,6 @@
       </p:sp>
       <p:sp>
         <p:nvSpPr>
-          <p:cNvPr name="Freeform 11" id="11"/>
-          <p:cNvSpPr/>
-          <p:nvPr/>
-        </p:nvSpPr>
-        <p:spPr>
-          <a:xfrm flipH="false" flipV="false" rot="0">
-            <a:off x="1032684" y="1037874"/>
-            <a:ext cx="432986" cy="585638"/>
-          </a:xfrm>
-          <a:custGeom>
-            <a:avLst/>
-            <a:gdLst/>
-            <a:ahLst/>
-            <a:cxnLst/>
-            <a:rect r="r" b="b" t="t" l="l"/>
-            <a:pathLst>
-              <a:path h="585638" w="432986">
-                <a:moveTo>
-                  <a:pt x="0" y="0"/>
-                </a:moveTo>
-                <a:lnTo>
-                  <a:pt x="432987" y="0"/>
-                </a:lnTo>
-                <a:lnTo>
-                  <a:pt x="432987" y="585638"/>
-                </a:lnTo>
-                <a:lnTo>
-                  <a:pt x="0" y="585638"/>
-                </a:lnTo>
-                <a:lnTo>
-                  <a:pt x="0" y="0"/>
-                </a:lnTo>
-                <a:close/>
-              </a:path>
-            </a:pathLst>
-          </a:custGeom>
-          <a:blipFill>
-            <a:blip r:embed="rId8">
-              <a:extLst>
-                <a:ext uri="{96DAC541-7B7A-43D3-8B79-37D633B846F1}">
-                  <asvg:svgBlip xmlns:asvg="http://schemas.microsoft.com/office/drawing/2016/SVG/main" r:embed="rId9"/>
-                </a:ext>
-              </a:extLst>
-            </a:blip>
-            <a:stretch>
-              <a:fillRect l="0" t="0" r="-21157" b="-4158"/>
-            </a:stretch>
-          </a:blipFill>
-        </p:spPr>
-        <p:txBody>
-          <a:bodyPr/>
-          <a:p/>
-        </p:txBody>
-      </p:sp>
-      <p:sp>
-        <p:nvSpPr>
-          <p:cNvPr name="TextBox 12" id="12"/>
-          <p:cNvSpPr txBox="true"/>
-          <p:nvPr/>
-        </p:nvSpPr>
-        <p:spPr>
-          <a:xfrm rot="0">
-            <a:off x="1268082" y="1198060"/>
-            <a:ext cx="1535820" cy="266699"/>
-          </a:xfrm>
-          <a:prstGeom prst="rect">
-            <a:avLst/>
-          </a:prstGeom>
-        </p:spPr>
-        <p:txBody>
-          <a:bodyPr anchor="t" rtlCol="false" tIns="0" lIns="0" bIns="0" rIns="0">
-            <a:spAutoFit/>
-          </a:bodyPr>
-          <a:lstStyle/>
-          <a:p>
-            <a:pPr algn="l">
-              <a:lnSpc>
-                <a:spcPts val="2100"/>
-              </a:lnSpc>
-            </a:pPr>
-            <a:r>
-              <a:rPr lang="en-US" sz="1500" b="true">
-                <a:solidFill>
-                  <a:srgbClr val="042147"/>
-                </a:solidFill>
-                <a:latin typeface="Cormorant Garamond Bold"/>
-                <a:ea typeface="Cormorant Garamond Bold"/>
-                <a:cs typeface="Cormorant Garamond Bold"/>
-                <a:sym typeface="Cormorant Garamond Bold"/>
-              </a:rPr>
-              <a:t/>
-            </a:r>
-          </a:p>
-        </p:txBody>
-      </p:sp>
-      <p:sp>
-        <p:nvSpPr>
-          <p:cNvPr name="Freeform 13" id="13"/>
-          <p:cNvSpPr/>
-          <p:nvPr/>
-        </p:nvSpPr>
-        <p:spPr>
-          <a:xfrm flipH="false" flipV="false" rot="0">
-            <a:off x="1032684" y="1050223"/>
-            <a:ext cx="474326" cy="588321"/>
-          </a:xfrm>
-          <a:custGeom>
-            <a:avLst/>
-            <a:gdLst/>
-            <a:ahLst/>
-            <a:cxnLst/>
-            <a:rect r="r" b="b" t="t" l="l"/>
-            <a:pathLst>
-              <a:path h="588321" w="474326">
-                <a:moveTo>
-                  <a:pt x="0" y="0"/>
-                </a:moveTo>
-                <a:lnTo>
-                  <a:pt x="474326" y="0"/>
-                </a:lnTo>
-                <a:lnTo>
-                  <a:pt x="474326" y="588322"/>
-                </a:lnTo>
-                <a:lnTo>
-                  <a:pt x="0" y="588322"/>
-                </a:lnTo>
-                <a:lnTo>
-                  <a:pt x="0" y="0"/>
-                </a:lnTo>
-                <a:close/>
-              </a:path>
-            </a:pathLst>
-          </a:custGeom>
-          <a:blipFill>
-            <a:blip r:embed="rId8">
-              <a:extLst>
-                <a:ext uri="{96DAC541-7B7A-43D3-8B79-37D633B846F1}">
-                  <asvg:svgBlip xmlns:asvg="http://schemas.microsoft.com/office/drawing/2016/SVG/main" r:embed="rId9"/>
-                </a:ext>
-              </a:extLst>
-            </a:blip>
-            <a:stretch>
-              <a:fillRect l="0" t="-2099" r="-10598" b="-1584"/>
-            </a:stretch>
-          </a:blipFill>
-        </p:spPr>
-        <p:txBody>
-          <a:bodyPr/>
-          <a:p/>
-        </p:txBody>
-      </p:sp>
-      <p:sp>
-        <p:nvSpPr>
           <p:cNvPr name="Freeform 14" id="14"/>
           <p:cNvSpPr/>
           <p:nvPr/>
@@ -7017,62 +6237,6 @@
       </p:sp>
       <p:sp>
         <p:nvSpPr>
-          <p:cNvPr name="Freeform 5" id="5"/>
-          <p:cNvSpPr/>
-          <p:nvPr/>
-        </p:nvSpPr>
-        <p:spPr>
-          <a:xfrm flipH="false" flipV="false" rot="-5400000">
-            <a:off x="304918" y="4761049"/>
-            <a:ext cx="1447564" cy="628188"/>
-          </a:xfrm>
-          <a:custGeom>
-            <a:avLst/>
-            <a:gdLst/>
-            <a:ahLst/>
-            <a:cxnLst/>
-            <a:rect r="r" b="b" t="t" l="l"/>
-            <a:pathLst>
-              <a:path h="628188" w="1447564">
-                <a:moveTo>
-                  <a:pt x="0" y="0"/>
-                </a:moveTo>
-                <a:lnTo>
-                  <a:pt x="1447564" y="0"/>
-                </a:lnTo>
-                <a:lnTo>
-                  <a:pt x="1447564" y="628188"/>
-                </a:lnTo>
-                <a:lnTo>
-                  <a:pt x="0" y="628188"/>
-                </a:lnTo>
-                <a:lnTo>
-                  <a:pt x="0" y="0"/>
-                </a:lnTo>
-                <a:close/>
-              </a:path>
-            </a:pathLst>
-          </a:custGeom>
-          <a:blipFill>
-            <a:blip r:embed="rId6">
-              <a:extLst>
-                <a:ext uri="{96DAC541-7B7A-43D3-8B79-37D633B846F1}">
-                  <asvg:svgBlip xmlns:asvg="http://schemas.microsoft.com/office/drawing/2016/SVG/main" r:embed="rId7"/>
-                </a:ext>
-              </a:extLst>
-            </a:blip>
-            <a:stretch>
-              <a:fillRect l="0" t="0" r="0" b="0"/>
-            </a:stretch>
-          </a:blipFill>
-        </p:spPr>
-        <p:txBody>
-          <a:bodyPr/>
-          <a:p/>
-        </p:txBody>
-      </p:sp>
-      <p:sp>
-        <p:nvSpPr>
           <p:cNvPr name="Freeform 6" id="6"/>
           <p:cNvSpPr/>
           <p:nvPr/>
@@ -7119,159 +6283,6 @@
             </a:blip>
             <a:stretch>
               <a:fillRect l="0" t="0" r="0" b="0"/>
-            </a:stretch>
-          </a:blipFill>
-        </p:spPr>
-        <p:txBody>
-          <a:bodyPr/>
-          <a:p/>
-        </p:txBody>
-      </p:sp>
-      <p:sp>
-        <p:nvSpPr>
-          <p:cNvPr name="Freeform 7" id="7"/>
-          <p:cNvSpPr/>
-          <p:nvPr/>
-        </p:nvSpPr>
-        <p:spPr>
-          <a:xfrm flipH="false" flipV="false" rot="0">
-            <a:off x="1032684" y="1037874"/>
-            <a:ext cx="432986" cy="585638"/>
-          </a:xfrm>
-          <a:custGeom>
-            <a:avLst/>
-            <a:gdLst/>
-            <a:ahLst/>
-            <a:cxnLst/>
-            <a:rect r="r" b="b" t="t" l="l"/>
-            <a:pathLst>
-              <a:path h="585638" w="432986">
-                <a:moveTo>
-                  <a:pt x="0" y="0"/>
-                </a:moveTo>
-                <a:lnTo>
-                  <a:pt x="432987" y="0"/>
-                </a:lnTo>
-                <a:lnTo>
-                  <a:pt x="432987" y="585638"/>
-                </a:lnTo>
-                <a:lnTo>
-                  <a:pt x="0" y="585638"/>
-                </a:lnTo>
-                <a:lnTo>
-                  <a:pt x="0" y="0"/>
-                </a:lnTo>
-                <a:close/>
-              </a:path>
-            </a:pathLst>
-          </a:custGeom>
-          <a:blipFill>
-            <a:blip r:embed="rId10">
-              <a:extLst>
-                <a:ext uri="{96DAC541-7B7A-43D3-8B79-37D633B846F1}">
-                  <asvg:svgBlip xmlns:asvg="http://schemas.microsoft.com/office/drawing/2016/SVG/main" r:embed="rId11"/>
-                </a:ext>
-              </a:extLst>
-            </a:blip>
-            <a:stretch>
-              <a:fillRect l="0" t="0" r="-21157" b="-4158"/>
-            </a:stretch>
-          </a:blipFill>
-        </p:spPr>
-        <p:txBody>
-          <a:bodyPr/>
-          <a:p/>
-        </p:txBody>
-      </p:sp>
-      <p:sp>
-        <p:nvSpPr>
-          <p:cNvPr name="TextBox 8" id="8"/>
-          <p:cNvSpPr txBox="true"/>
-          <p:nvPr/>
-        </p:nvSpPr>
-        <p:spPr>
-          <a:xfrm rot="0">
-            <a:off x="1268082" y="1198060"/>
-            <a:ext cx="1535820" cy="266699"/>
-          </a:xfrm>
-          <a:prstGeom prst="rect">
-            <a:avLst/>
-          </a:prstGeom>
-        </p:spPr>
-        <p:txBody>
-          <a:bodyPr anchor="t" rtlCol="false" tIns="0" lIns="0" bIns="0" rIns="0">
-            <a:spAutoFit/>
-          </a:bodyPr>
-          <a:lstStyle/>
-          <a:p>
-            <a:pPr algn="l">
-              <a:lnSpc>
-                <a:spcPts val="2100"/>
-              </a:lnSpc>
-            </a:pPr>
-            <a:r>
-              <a:rPr lang="en-US" sz="1500" b="true">
-                <a:solidFill>
-                  <a:srgbClr val="042147"/>
-                </a:solidFill>
-                <a:latin typeface="Cormorant Garamond Bold"/>
-                <a:ea typeface="Cormorant Garamond Bold"/>
-                <a:cs typeface="Cormorant Garamond Bold"/>
-                <a:sym typeface="Cormorant Garamond Bold"/>
-              </a:rPr>
-              <a:t/>
-            </a:r>
-          </a:p>
-        </p:txBody>
-      </p:sp>
-      <p:sp>
-        <p:nvSpPr>
-          <p:cNvPr name="Freeform 9" id="9"/>
-          <p:cNvSpPr/>
-          <p:nvPr/>
-        </p:nvSpPr>
-        <p:spPr>
-          <a:xfrm flipH="false" flipV="false" rot="0">
-            <a:off x="1032684" y="1050223"/>
-            <a:ext cx="474326" cy="588321"/>
-          </a:xfrm>
-          <a:custGeom>
-            <a:avLst/>
-            <a:gdLst/>
-            <a:ahLst/>
-            <a:cxnLst/>
-            <a:rect r="r" b="b" t="t" l="l"/>
-            <a:pathLst>
-              <a:path h="588321" w="474326">
-                <a:moveTo>
-                  <a:pt x="0" y="0"/>
-                </a:moveTo>
-                <a:lnTo>
-                  <a:pt x="474326" y="0"/>
-                </a:lnTo>
-                <a:lnTo>
-                  <a:pt x="474326" y="588322"/>
-                </a:lnTo>
-                <a:lnTo>
-                  <a:pt x="0" y="588322"/>
-                </a:lnTo>
-                <a:lnTo>
-                  <a:pt x="0" y="0"/>
-                </a:lnTo>
-                <a:close/>
-              </a:path>
-            </a:pathLst>
-          </a:custGeom>
-          <a:blipFill>
-            <a:blip r:embed="rId10">
-              <a:extLst>
-                <a:ext uri="{96DAC541-7B7A-43D3-8B79-37D633B846F1}">
-                  <asvg:svgBlip xmlns:asvg="http://schemas.microsoft.com/office/drawing/2016/SVG/main" r:embed="rId11"/>
-                </a:ext>
-              </a:extLst>
-            </a:blip>
-            <a:stretch>
-              <a:fillRect l="0" t="-2099" r="-10598" b="-1584"/>
             </a:stretch>
           </a:blipFill>
         </p:spPr>
@@ -7468,62 +6479,6 @@
       </p:sp>
       <p:sp>
         <p:nvSpPr>
-          <p:cNvPr name="Freeform 4" id="4"/>
-          <p:cNvSpPr/>
-          <p:nvPr/>
-        </p:nvSpPr>
-        <p:spPr>
-          <a:xfrm flipH="false" flipV="false" rot="0">
-            <a:off x="15238863" y="714606"/>
-            <a:ext cx="1447564" cy="628188"/>
-          </a:xfrm>
-          <a:custGeom>
-            <a:avLst/>
-            <a:gdLst/>
-            <a:ahLst/>
-            <a:cxnLst/>
-            <a:rect r="r" b="b" t="t" l="l"/>
-            <a:pathLst>
-              <a:path h="628188" w="1447564">
-                <a:moveTo>
-                  <a:pt x="0" y="0"/>
-                </a:moveTo>
-                <a:lnTo>
-                  <a:pt x="1447564" y="0"/>
-                </a:lnTo>
-                <a:lnTo>
-                  <a:pt x="1447564" y="628188"/>
-                </a:lnTo>
-                <a:lnTo>
-                  <a:pt x="0" y="628188"/>
-                </a:lnTo>
-                <a:lnTo>
-                  <a:pt x="0" y="0"/>
-                </a:lnTo>
-                <a:close/>
-              </a:path>
-            </a:pathLst>
-          </a:custGeom>
-          <a:blipFill>
-            <a:blip r:embed="rId6">
-              <a:extLst>
-                <a:ext uri="{96DAC541-7B7A-43D3-8B79-37D633B846F1}">
-                  <asvg:svgBlip xmlns:asvg="http://schemas.microsoft.com/office/drawing/2016/SVG/main" r:embed="rId7"/>
-                </a:ext>
-              </a:extLst>
-            </a:blip>
-            <a:stretch>
-              <a:fillRect l="0" t="0" r="0" b="0"/>
-            </a:stretch>
-          </a:blipFill>
-        </p:spPr>
-        <p:txBody>
-          <a:bodyPr/>
-          <a:p/>
-        </p:txBody>
-      </p:sp>
-      <p:sp>
-        <p:nvSpPr>
           <p:cNvPr name="Freeform 5" id="5"/>
           <p:cNvSpPr/>
           <p:nvPr/>
@@ -7571,159 +6526,6 @@
             </a:blip>
             <a:stretch>
               <a:fillRect l="0" t="0" r="0" b="0"/>
-            </a:stretch>
-          </a:blipFill>
-        </p:spPr>
-        <p:txBody>
-          <a:bodyPr/>
-          <a:p/>
-        </p:txBody>
-      </p:sp>
-      <p:sp>
-        <p:nvSpPr>
-          <p:cNvPr name="Freeform 6" id="6"/>
-          <p:cNvSpPr/>
-          <p:nvPr/>
-        </p:nvSpPr>
-        <p:spPr>
-          <a:xfrm flipH="false" flipV="false" rot="0">
-            <a:off x="1032684" y="1037874"/>
-            <a:ext cx="432986" cy="585638"/>
-          </a:xfrm>
-          <a:custGeom>
-            <a:avLst/>
-            <a:gdLst/>
-            <a:ahLst/>
-            <a:cxnLst/>
-            <a:rect r="r" b="b" t="t" l="l"/>
-            <a:pathLst>
-              <a:path h="585638" w="432986">
-                <a:moveTo>
-                  <a:pt x="0" y="0"/>
-                </a:moveTo>
-                <a:lnTo>
-                  <a:pt x="432987" y="0"/>
-                </a:lnTo>
-                <a:lnTo>
-                  <a:pt x="432987" y="585638"/>
-                </a:lnTo>
-                <a:lnTo>
-                  <a:pt x="0" y="585638"/>
-                </a:lnTo>
-                <a:lnTo>
-                  <a:pt x="0" y="0"/>
-                </a:lnTo>
-                <a:close/>
-              </a:path>
-            </a:pathLst>
-          </a:custGeom>
-          <a:blipFill>
-            <a:blip r:embed="rId8">
-              <a:extLst>
-                <a:ext uri="{96DAC541-7B7A-43D3-8B79-37D633B846F1}">
-                  <asvg:svgBlip xmlns:asvg="http://schemas.microsoft.com/office/drawing/2016/SVG/main" r:embed="rId9"/>
-                </a:ext>
-              </a:extLst>
-            </a:blip>
-            <a:stretch>
-              <a:fillRect l="0" t="0" r="-21157" b="-4158"/>
-            </a:stretch>
-          </a:blipFill>
-        </p:spPr>
-        <p:txBody>
-          <a:bodyPr/>
-          <a:p/>
-        </p:txBody>
-      </p:sp>
-      <p:sp>
-        <p:nvSpPr>
-          <p:cNvPr name="TextBox 7" id="7"/>
-          <p:cNvSpPr txBox="true"/>
-          <p:nvPr/>
-        </p:nvSpPr>
-        <p:spPr>
-          <a:xfrm rot="0">
-            <a:off x="1268082" y="1198060"/>
-            <a:ext cx="1535820" cy="266699"/>
-          </a:xfrm>
-          <a:prstGeom prst="rect">
-            <a:avLst/>
-          </a:prstGeom>
-        </p:spPr>
-        <p:txBody>
-          <a:bodyPr anchor="t" rtlCol="false" tIns="0" lIns="0" bIns="0" rIns="0">
-            <a:spAutoFit/>
-          </a:bodyPr>
-          <a:lstStyle/>
-          <a:p>
-            <a:pPr algn="l">
-              <a:lnSpc>
-                <a:spcPts val="2100"/>
-              </a:lnSpc>
-            </a:pPr>
-            <a:r>
-              <a:rPr lang="en-US" sz="1500" b="true">
-                <a:solidFill>
-                  <a:srgbClr val="042147"/>
-                </a:solidFill>
-                <a:latin typeface="Cormorant Garamond Bold"/>
-                <a:ea typeface="Cormorant Garamond Bold"/>
-                <a:cs typeface="Cormorant Garamond Bold"/>
-                <a:sym typeface="Cormorant Garamond Bold"/>
-              </a:rPr>
-              <a:t/>
-            </a:r>
-          </a:p>
-        </p:txBody>
-      </p:sp>
-      <p:sp>
-        <p:nvSpPr>
-          <p:cNvPr name="Freeform 8" id="8"/>
-          <p:cNvSpPr/>
-          <p:nvPr/>
-        </p:nvSpPr>
-        <p:spPr>
-          <a:xfrm flipH="false" flipV="false" rot="0">
-            <a:off x="1032684" y="1050223"/>
-            <a:ext cx="474326" cy="588321"/>
-          </a:xfrm>
-          <a:custGeom>
-            <a:avLst/>
-            <a:gdLst/>
-            <a:ahLst/>
-            <a:cxnLst/>
-            <a:rect r="r" b="b" t="t" l="l"/>
-            <a:pathLst>
-              <a:path h="588321" w="474326">
-                <a:moveTo>
-                  <a:pt x="0" y="0"/>
-                </a:moveTo>
-                <a:lnTo>
-                  <a:pt x="474326" y="0"/>
-                </a:lnTo>
-                <a:lnTo>
-                  <a:pt x="474326" y="588322"/>
-                </a:lnTo>
-                <a:lnTo>
-                  <a:pt x="0" y="588322"/>
-                </a:lnTo>
-                <a:lnTo>
-                  <a:pt x="0" y="0"/>
-                </a:lnTo>
-                <a:close/>
-              </a:path>
-            </a:pathLst>
-          </a:custGeom>
-          <a:blipFill>
-            <a:blip r:embed="rId8">
-              <a:extLst>
-                <a:ext uri="{96DAC541-7B7A-43D3-8B79-37D633B846F1}">
-                  <asvg:svgBlip xmlns:asvg="http://schemas.microsoft.com/office/drawing/2016/SVG/main" r:embed="rId9"/>
-                </a:ext>
-              </a:extLst>
-            </a:blip>
-            <a:stretch>
-              <a:fillRect l="0" t="-2099" r="-10598" b="-1584"/>
             </a:stretch>
           </a:blipFill>
         </p:spPr>
@@ -8434,62 +7236,6 @@
       </p:sp>
       <p:sp>
         <p:nvSpPr>
-          <p:cNvPr name="Freeform 5" id="5"/>
-          <p:cNvSpPr/>
-          <p:nvPr/>
-        </p:nvSpPr>
-        <p:spPr>
-          <a:xfrm flipH="false" flipV="false" rot="0">
-            <a:off x="5302619" y="8944206"/>
-            <a:ext cx="1447564" cy="628188"/>
-          </a:xfrm>
-          <a:custGeom>
-            <a:avLst/>
-            <a:gdLst/>
-            <a:ahLst/>
-            <a:cxnLst/>
-            <a:rect r="r" b="b" t="t" l="l"/>
-            <a:pathLst>
-              <a:path h="628188" w="1447564">
-                <a:moveTo>
-                  <a:pt x="0" y="0"/>
-                </a:moveTo>
-                <a:lnTo>
-                  <a:pt x="1447564" y="0"/>
-                </a:lnTo>
-                <a:lnTo>
-                  <a:pt x="1447564" y="628188"/>
-                </a:lnTo>
-                <a:lnTo>
-                  <a:pt x="0" y="628188"/>
-                </a:lnTo>
-                <a:lnTo>
-                  <a:pt x="0" y="0"/>
-                </a:lnTo>
-                <a:close/>
-              </a:path>
-            </a:pathLst>
-          </a:custGeom>
-          <a:blipFill>
-            <a:blip r:embed="rId6">
-              <a:extLst>
-                <a:ext uri="{96DAC541-7B7A-43D3-8B79-37D633B846F1}">
-                  <asvg:svgBlip xmlns:asvg="http://schemas.microsoft.com/office/drawing/2016/SVG/main" r:embed="rId7"/>
-                </a:ext>
-              </a:extLst>
-            </a:blip>
-            <a:stretch>
-              <a:fillRect l="0" t="0" r="0" b="0"/>
-            </a:stretch>
-          </a:blipFill>
-        </p:spPr>
-        <p:txBody>
-          <a:bodyPr/>
-          <a:p/>
-        </p:txBody>
-      </p:sp>
-      <p:sp>
-        <p:nvSpPr>
           <p:cNvPr name="Freeform 6" id="6"/>
           <p:cNvSpPr/>
           <p:nvPr/>
@@ -8593,159 +7339,6 @@
             </a:blip>
             <a:stretch>
               <a:fillRect l="0" t="0" r="0" b="0"/>
-            </a:stretch>
-          </a:blipFill>
-        </p:spPr>
-        <p:txBody>
-          <a:bodyPr/>
-          <a:p/>
-        </p:txBody>
-      </p:sp>
-      <p:sp>
-        <p:nvSpPr>
-          <p:cNvPr name="Freeform 8" id="8"/>
-          <p:cNvSpPr/>
-          <p:nvPr/>
-        </p:nvSpPr>
-        <p:spPr>
-          <a:xfrm flipH="false" flipV="false" rot="0">
-            <a:off x="1032684" y="1037874"/>
-            <a:ext cx="432986" cy="585638"/>
-          </a:xfrm>
-          <a:custGeom>
-            <a:avLst/>
-            <a:gdLst/>
-            <a:ahLst/>
-            <a:cxnLst/>
-            <a:rect r="r" b="b" t="t" l="l"/>
-            <a:pathLst>
-              <a:path h="585638" w="432986">
-                <a:moveTo>
-                  <a:pt x="0" y="0"/>
-                </a:moveTo>
-                <a:lnTo>
-                  <a:pt x="432987" y="0"/>
-                </a:lnTo>
-                <a:lnTo>
-                  <a:pt x="432987" y="585638"/>
-                </a:lnTo>
-                <a:lnTo>
-                  <a:pt x="0" y="585638"/>
-                </a:lnTo>
-                <a:lnTo>
-                  <a:pt x="0" y="0"/>
-                </a:lnTo>
-                <a:close/>
-              </a:path>
-            </a:pathLst>
-          </a:custGeom>
-          <a:blipFill>
-            <a:blip r:embed="rId10">
-              <a:extLst>
-                <a:ext uri="{96DAC541-7B7A-43D3-8B79-37D633B846F1}">
-                  <asvg:svgBlip xmlns:asvg="http://schemas.microsoft.com/office/drawing/2016/SVG/main" r:embed="rId11"/>
-                </a:ext>
-              </a:extLst>
-            </a:blip>
-            <a:stretch>
-              <a:fillRect l="0" t="0" r="-21157" b="-4158"/>
-            </a:stretch>
-          </a:blipFill>
-        </p:spPr>
-        <p:txBody>
-          <a:bodyPr/>
-          <a:p/>
-        </p:txBody>
-      </p:sp>
-      <p:sp>
-        <p:nvSpPr>
-          <p:cNvPr name="TextBox 9" id="9"/>
-          <p:cNvSpPr txBox="true"/>
-          <p:nvPr/>
-        </p:nvSpPr>
-        <p:spPr>
-          <a:xfrm rot="0">
-            <a:off x="1268082" y="1198060"/>
-            <a:ext cx="1535820" cy="266699"/>
-          </a:xfrm>
-          <a:prstGeom prst="rect">
-            <a:avLst/>
-          </a:prstGeom>
-        </p:spPr>
-        <p:txBody>
-          <a:bodyPr anchor="t" rtlCol="false" tIns="0" lIns="0" bIns="0" rIns="0">
-            <a:spAutoFit/>
-          </a:bodyPr>
-          <a:lstStyle/>
-          <a:p>
-            <a:pPr algn="l">
-              <a:lnSpc>
-                <a:spcPts val="2100"/>
-              </a:lnSpc>
-            </a:pPr>
-            <a:r>
-              <a:rPr lang="en-US" sz="1500" b="true">
-                <a:solidFill>
-                  <a:srgbClr val="042147"/>
-                </a:solidFill>
-                <a:latin typeface="Cormorant Garamond Bold"/>
-                <a:ea typeface="Cormorant Garamond Bold"/>
-                <a:cs typeface="Cormorant Garamond Bold"/>
-                <a:sym typeface="Cormorant Garamond Bold"/>
-              </a:rPr>
-              <a:t/>
-            </a:r>
-          </a:p>
-        </p:txBody>
-      </p:sp>
-      <p:sp>
-        <p:nvSpPr>
-          <p:cNvPr name="Freeform 10" id="10"/>
-          <p:cNvSpPr/>
-          <p:nvPr/>
-        </p:nvSpPr>
-        <p:spPr>
-          <a:xfrm flipH="false" flipV="false" rot="0">
-            <a:off x="1032684" y="1050223"/>
-            <a:ext cx="474326" cy="588321"/>
-          </a:xfrm>
-          <a:custGeom>
-            <a:avLst/>
-            <a:gdLst/>
-            <a:ahLst/>
-            <a:cxnLst/>
-            <a:rect r="r" b="b" t="t" l="l"/>
-            <a:pathLst>
-              <a:path h="588321" w="474326">
-                <a:moveTo>
-                  <a:pt x="0" y="0"/>
-                </a:moveTo>
-                <a:lnTo>
-                  <a:pt x="474326" y="0"/>
-                </a:lnTo>
-                <a:lnTo>
-                  <a:pt x="474326" y="588322"/>
-                </a:lnTo>
-                <a:lnTo>
-                  <a:pt x="0" y="588322"/>
-                </a:lnTo>
-                <a:lnTo>
-                  <a:pt x="0" y="0"/>
-                </a:lnTo>
-                <a:close/>
-              </a:path>
-            </a:pathLst>
-          </a:custGeom>
-          <a:blipFill>
-            <a:blip r:embed="rId10">
-              <a:extLst>
-                <a:ext uri="{96DAC541-7B7A-43D3-8B79-37D633B846F1}">
-                  <asvg:svgBlip xmlns:asvg="http://schemas.microsoft.com/office/drawing/2016/SVG/main" r:embed="rId11"/>
-                </a:ext>
-              </a:extLst>
-            </a:blip>
-            <a:stretch>
-              <a:fillRect l="0" t="-2099" r="-10598" b="-1584"/>
             </a:stretch>
           </a:blipFill>
         </p:spPr>
@@ -9131,62 +7724,6 @@
       </p:sp>
       <p:sp>
         <p:nvSpPr>
-          <p:cNvPr name="Freeform 5" id="5"/>
-          <p:cNvSpPr/>
-          <p:nvPr/>
-        </p:nvSpPr>
-        <p:spPr>
-          <a:xfrm flipH="false" flipV="false" rot="-5400000">
-            <a:off x="308903" y="5851351"/>
-            <a:ext cx="1447564" cy="628188"/>
-          </a:xfrm>
-          <a:custGeom>
-            <a:avLst/>
-            <a:gdLst/>
-            <a:ahLst/>
-            <a:cxnLst/>
-            <a:rect r="r" b="b" t="t" l="l"/>
-            <a:pathLst>
-              <a:path h="628188" w="1447564">
-                <a:moveTo>
-                  <a:pt x="0" y="0"/>
-                </a:moveTo>
-                <a:lnTo>
-                  <a:pt x="1447563" y="0"/>
-                </a:lnTo>
-                <a:lnTo>
-                  <a:pt x="1447563" y="628189"/>
-                </a:lnTo>
-                <a:lnTo>
-                  <a:pt x="0" y="628189"/>
-                </a:lnTo>
-                <a:lnTo>
-                  <a:pt x="0" y="0"/>
-                </a:lnTo>
-                <a:close/>
-              </a:path>
-            </a:pathLst>
-          </a:custGeom>
-          <a:blipFill>
-            <a:blip r:embed="rId4">
-              <a:extLst>
-                <a:ext uri="{96DAC541-7B7A-43D3-8B79-37D633B846F1}">
-                  <asvg:svgBlip xmlns:asvg="http://schemas.microsoft.com/office/drawing/2016/SVG/main" r:embed="rId5"/>
-                </a:ext>
-              </a:extLst>
-            </a:blip>
-            <a:stretch>
-              <a:fillRect l="0" t="0" r="0" b="0"/>
-            </a:stretch>
-          </a:blipFill>
-        </p:spPr>
-        <p:txBody>
-          <a:bodyPr/>
-          <a:p/>
-        </p:txBody>
-      </p:sp>
-      <p:sp>
-        <p:nvSpPr>
           <p:cNvPr name="TextBox 6" id="6"/>
           <p:cNvSpPr txBox="true"/>
           <p:nvPr/>
@@ -9402,159 +7939,6 @@
         <p:txBody>
           <a:bodyPr/>
           <a:p/>
-        </p:txBody>
-      </p:sp>
-      <p:sp>
-        <p:nvSpPr>
-          <p:cNvPr name="Freeform 9" id="9"/>
-          <p:cNvSpPr/>
-          <p:nvPr/>
-        </p:nvSpPr>
-        <p:spPr>
-          <a:xfrm flipH="false" flipV="false" rot="0">
-            <a:off x="1032684" y="1037874"/>
-            <a:ext cx="432986" cy="585638"/>
-          </a:xfrm>
-          <a:custGeom>
-            <a:avLst/>
-            <a:gdLst/>
-            <a:ahLst/>
-            <a:cxnLst/>
-            <a:rect r="r" b="b" t="t" l="l"/>
-            <a:pathLst>
-              <a:path h="585638" w="432986">
-                <a:moveTo>
-                  <a:pt x="0" y="0"/>
-                </a:moveTo>
-                <a:lnTo>
-                  <a:pt x="432987" y="0"/>
-                </a:lnTo>
-                <a:lnTo>
-                  <a:pt x="432987" y="585638"/>
-                </a:lnTo>
-                <a:lnTo>
-                  <a:pt x="0" y="585638"/>
-                </a:lnTo>
-                <a:lnTo>
-                  <a:pt x="0" y="0"/>
-                </a:lnTo>
-                <a:close/>
-              </a:path>
-            </a:pathLst>
-          </a:custGeom>
-          <a:blipFill>
-            <a:blip r:embed="rId10">
-              <a:extLst>
-                <a:ext uri="{96DAC541-7B7A-43D3-8B79-37D633B846F1}">
-                  <asvg:svgBlip xmlns:asvg="http://schemas.microsoft.com/office/drawing/2016/SVG/main" r:embed="rId11"/>
-                </a:ext>
-              </a:extLst>
-            </a:blip>
-            <a:stretch>
-              <a:fillRect l="0" t="0" r="-21157" b="-4158"/>
-            </a:stretch>
-          </a:blipFill>
-        </p:spPr>
-        <p:txBody>
-          <a:bodyPr/>
-          <a:p/>
-        </p:txBody>
-      </p:sp>
-      <p:sp>
-        <p:nvSpPr>
-          <p:cNvPr name="Freeform 10" id="10"/>
-          <p:cNvSpPr/>
-          <p:nvPr/>
-        </p:nvSpPr>
-        <p:spPr>
-          <a:xfrm flipH="false" flipV="false" rot="0">
-            <a:off x="1032684" y="1050223"/>
-            <a:ext cx="474326" cy="588321"/>
-          </a:xfrm>
-          <a:custGeom>
-            <a:avLst/>
-            <a:gdLst/>
-            <a:ahLst/>
-            <a:cxnLst/>
-            <a:rect r="r" b="b" t="t" l="l"/>
-            <a:pathLst>
-              <a:path h="588321" w="474326">
-                <a:moveTo>
-                  <a:pt x="0" y="0"/>
-                </a:moveTo>
-                <a:lnTo>
-                  <a:pt x="474326" y="0"/>
-                </a:lnTo>
-                <a:lnTo>
-                  <a:pt x="474326" y="588322"/>
-                </a:lnTo>
-                <a:lnTo>
-                  <a:pt x="0" y="588322"/>
-                </a:lnTo>
-                <a:lnTo>
-                  <a:pt x="0" y="0"/>
-                </a:lnTo>
-                <a:close/>
-              </a:path>
-            </a:pathLst>
-          </a:custGeom>
-          <a:blipFill>
-            <a:blip r:embed="rId10">
-              <a:extLst>
-                <a:ext uri="{96DAC541-7B7A-43D3-8B79-37D633B846F1}">
-                  <asvg:svgBlip xmlns:asvg="http://schemas.microsoft.com/office/drawing/2016/SVG/main" r:embed="rId11"/>
-                </a:ext>
-              </a:extLst>
-            </a:blip>
-            <a:stretch>
-              <a:fillRect l="0" t="-2099" r="-10598" b="-1584"/>
-            </a:stretch>
-          </a:blipFill>
-        </p:spPr>
-        <p:txBody>
-          <a:bodyPr/>
-          <a:p/>
-        </p:txBody>
-      </p:sp>
-      <p:sp>
-        <p:nvSpPr>
-          <p:cNvPr name="TextBox 11" id="11"/>
-          <p:cNvSpPr txBox="true"/>
-          <p:nvPr/>
-        </p:nvSpPr>
-        <p:spPr>
-          <a:xfrm rot="0">
-            <a:off x="1268082" y="1198060"/>
-            <a:ext cx="1535820" cy="266699"/>
-          </a:xfrm>
-          <a:prstGeom prst="rect">
-            <a:avLst/>
-          </a:prstGeom>
-        </p:spPr>
-        <p:txBody>
-          <a:bodyPr anchor="t" rtlCol="false" tIns="0" lIns="0" bIns="0" rIns="0">
-            <a:spAutoFit/>
-          </a:bodyPr>
-          <a:lstStyle/>
-          <a:p>
-            <a:pPr algn="l">
-              <a:lnSpc>
-                <a:spcPts val="2100"/>
-              </a:lnSpc>
-            </a:pPr>
-            <a:r>
-              <a:rPr lang="en-US" sz="1500" b="true">
-                <a:solidFill>
-                  <a:srgbClr val="042147"/>
-                </a:solidFill>
-                <a:latin typeface="Cormorant Garamond Bold"/>
-                <a:ea typeface="Cormorant Garamond Bold"/>
-                <a:cs typeface="Cormorant Garamond Bold"/>
-                <a:sym typeface="Cormorant Garamond Bold"/>
-              </a:rPr>
-              <a:t/>
-            </a:r>
-          </a:p>
         </p:txBody>
       </p:sp>
       <p:grpSp>
@@ -9960,62 +8344,6 @@
       </p:sp>
       <p:sp>
         <p:nvSpPr>
-          <p:cNvPr name="Freeform 7" id="7"/>
-          <p:cNvSpPr/>
-          <p:nvPr/>
-        </p:nvSpPr>
-        <p:spPr>
-          <a:xfrm flipH="false" flipV="false" rot="0">
-            <a:off x="10359304" y="8944206"/>
-            <a:ext cx="1447564" cy="628188"/>
-          </a:xfrm>
-          <a:custGeom>
-            <a:avLst/>
-            <a:gdLst/>
-            <a:ahLst/>
-            <a:cxnLst/>
-            <a:rect r="r" b="b" t="t" l="l"/>
-            <a:pathLst>
-              <a:path h="628188" w="1447564">
-                <a:moveTo>
-                  <a:pt x="0" y="0"/>
-                </a:moveTo>
-                <a:lnTo>
-                  <a:pt x="1447564" y="0"/>
-                </a:lnTo>
-                <a:lnTo>
-                  <a:pt x="1447564" y="628188"/>
-                </a:lnTo>
-                <a:lnTo>
-                  <a:pt x="0" y="628188"/>
-                </a:lnTo>
-                <a:lnTo>
-                  <a:pt x="0" y="0"/>
-                </a:lnTo>
-                <a:close/>
-              </a:path>
-            </a:pathLst>
-          </a:custGeom>
-          <a:blipFill>
-            <a:blip r:embed="rId6">
-              <a:extLst>
-                <a:ext uri="{96DAC541-7B7A-43D3-8B79-37D633B846F1}">
-                  <asvg:svgBlip xmlns:asvg="http://schemas.microsoft.com/office/drawing/2016/SVG/main" r:embed="rId7"/>
-                </a:ext>
-              </a:extLst>
-            </a:blip>
-            <a:stretch>
-              <a:fillRect l="0" t="0" r="0" b="0"/>
-            </a:stretch>
-          </a:blipFill>
-        </p:spPr>
-        <p:txBody>
-          <a:bodyPr/>
-          <a:p/>
-        </p:txBody>
-      </p:sp>
-      <p:sp>
-        <p:nvSpPr>
           <p:cNvPr name="Freeform 8" id="8"/>
           <p:cNvSpPr/>
           <p:nvPr/>
@@ -10203,159 +8531,6 @@
             </a:blip>
             <a:stretch>
               <a:fillRect l="0" t="0" r="0" b="0"/>
-            </a:stretch>
-          </a:blipFill>
-        </p:spPr>
-        <p:txBody>
-          <a:bodyPr/>
-          <a:p/>
-        </p:txBody>
-      </p:sp>
-      <p:sp>
-        <p:nvSpPr>
-          <p:cNvPr name="Freeform 13" id="13"/>
-          <p:cNvSpPr/>
-          <p:nvPr/>
-        </p:nvSpPr>
-        <p:spPr>
-          <a:xfrm flipH="false" flipV="false" rot="0">
-            <a:off x="1032684" y="1037874"/>
-            <a:ext cx="432986" cy="585638"/>
-          </a:xfrm>
-          <a:custGeom>
-            <a:avLst/>
-            <a:gdLst/>
-            <a:ahLst/>
-            <a:cxnLst/>
-            <a:rect r="r" b="b" t="t" l="l"/>
-            <a:pathLst>
-              <a:path h="585638" w="432986">
-                <a:moveTo>
-                  <a:pt x="0" y="0"/>
-                </a:moveTo>
-                <a:lnTo>
-                  <a:pt x="432987" y="0"/>
-                </a:lnTo>
-                <a:lnTo>
-                  <a:pt x="432987" y="585638"/>
-                </a:lnTo>
-                <a:lnTo>
-                  <a:pt x="0" y="585638"/>
-                </a:lnTo>
-                <a:lnTo>
-                  <a:pt x="0" y="0"/>
-                </a:lnTo>
-                <a:close/>
-              </a:path>
-            </a:pathLst>
-          </a:custGeom>
-          <a:blipFill>
-            <a:blip r:embed="rId12">
-              <a:extLst>
-                <a:ext uri="{96DAC541-7B7A-43D3-8B79-37D633B846F1}">
-                  <asvg:svgBlip xmlns:asvg="http://schemas.microsoft.com/office/drawing/2016/SVG/main" r:embed="rId13"/>
-                </a:ext>
-              </a:extLst>
-            </a:blip>
-            <a:stretch>
-              <a:fillRect l="0" t="0" r="-21157" b="-4158"/>
-            </a:stretch>
-          </a:blipFill>
-        </p:spPr>
-        <p:txBody>
-          <a:bodyPr/>
-          <a:p/>
-        </p:txBody>
-      </p:sp>
-      <p:sp>
-        <p:nvSpPr>
-          <p:cNvPr name="TextBox 14" id="14"/>
-          <p:cNvSpPr txBox="true"/>
-          <p:nvPr/>
-        </p:nvSpPr>
-        <p:spPr>
-          <a:xfrm rot="0">
-            <a:off x="1268082" y="1198060"/>
-            <a:ext cx="1535820" cy="266699"/>
-          </a:xfrm>
-          <a:prstGeom prst="rect">
-            <a:avLst/>
-          </a:prstGeom>
-        </p:spPr>
-        <p:txBody>
-          <a:bodyPr anchor="t" rtlCol="false" tIns="0" lIns="0" bIns="0" rIns="0">
-            <a:spAutoFit/>
-          </a:bodyPr>
-          <a:lstStyle/>
-          <a:p>
-            <a:pPr algn="l">
-              <a:lnSpc>
-                <a:spcPts val="2100"/>
-              </a:lnSpc>
-            </a:pPr>
-            <a:r>
-              <a:rPr lang="en-US" sz="1500" b="true">
-                <a:solidFill>
-                  <a:srgbClr val="042147"/>
-                </a:solidFill>
-                <a:latin typeface="Cormorant Garamond Bold"/>
-                <a:ea typeface="Cormorant Garamond Bold"/>
-                <a:cs typeface="Cormorant Garamond Bold"/>
-                <a:sym typeface="Cormorant Garamond Bold"/>
-              </a:rPr>
-              <a:t/>
-            </a:r>
-          </a:p>
-        </p:txBody>
-      </p:sp>
-      <p:sp>
-        <p:nvSpPr>
-          <p:cNvPr name="Freeform 15" id="15"/>
-          <p:cNvSpPr/>
-          <p:nvPr/>
-        </p:nvSpPr>
-        <p:spPr>
-          <a:xfrm flipH="false" flipV="false" rot="0">
-            <a:off x="1032684" y="1050223"/>
-            <a:ext cx="474326" cy="588321"/>
-          </a:xfrm>
-          <a:custGeom>
-            <a:avLst/>
-            <a:gdLst/>
-            <a:ahLst/>
-            <a:cxnLst/>
-            <a:rect r="r" b="b" t="t" l="l"/>
-            <a:pathLst>
-              <a:path h="588321" w="474326">
-                <a:moveTo>
-                  <a:pt x="0" y="0"/>
-                </a:moveTo>
-                <a:lnTo>
-                  <a:pt x="474326" y="0"/>
-                </a:lnTo>
-                <a:lnTo>
-                  <a:pt x="474326" y="588322"/>
-                </a:lnTo>
-                <a:lnTo>
-                  <a:pt x="0" y="588322"/>
-                </a:lnTo>
-                <a:lnTo>
-                  <a:pt x="0" y="0"/>
-                </a:lnTo>
-                <a:close/>
-              </a:path>
-            </a:pathLst>
-          </a:custGeom>
-          <a:blipFill>
-            <a:blip r:embed="rId12">
-              <a:extLst>
-                <a:ext uri="{96DAC541-7B7A-43D3-8B79-37D633B846F1}">
-                  <asvg:svgBlip xmlns:asvg="http://schemas.microsoft.com/office/drawing/2016/SVG/main" r:embed="rId13"/>
-                </a:ext>
-              </a:extLst>
-            </a:blip>
-            <a:stretch>
-              <a:fillRect l="0" t="-2099" r="-10598" b="-1584"/>
             </a:stretch>
           </a:blipFill>
         </p:spPr>
@@ -11306,62 +9481,6 @@
       </p:sp>
       <p:sp>
         <p:nvSpPr>
-          <p:cNvPr name="Freeform 5" id="5"/>
-          <p:cNvSpPr/>
-          <p:nvPr/>
-        </p:nvSpPr>
-        <p:spPr>
-          <a:xfrm flipH="false" flipV="false" rot="0">
-            <a:off x="15811736" y="736129"/>
-            <a:ext cx="1447564" cy="628188"/>
-          </a:xfrm>
-          <a:custGeom>
-            <a:avLst/>
-            <a:gdLst/>
-            <a:ahLst/>
-            <a:cxnLst/>
-            <a:rect r="r" b="b" t="t" l="l"/>
-            <a:pathLst>
-              <a:path h="628188" w="1447564">
-                <a:moveTo>
-                  <a:pt x="0" y="0"/>
-                </a:moveTo>
-                <a:lnTo>
-                  <a:pt x="1447564" y="0"/>
-                </a:lnTo>
-                <a:lnTo>
-                  <a:pt x="1447564" y="628188"/>
-                </a:lnTo>
-                <a:lnTo>
-                  <a:pt x="0" y="628188"/>
-                </a:lnTo>
-                <a:lnTo>
-                  <a:pt x="0" y="0"/>
-                </a:lnTo>
-                <a:close/>
-              </a:path>
-            </a:pathLst>
-          </a:custGeom>
-          <a:blipFill>
-            <a:blip r:embed="rId6">
-              <a:extLst>
-                <a:ext uri="{96DAC541-7B7A-43D3-8B79-37D633B846F1}">
-                  <asvg:svgBlip xmlns:asvg="http://schemas.microsoft.com/office/drawing/2016/SVG/main" r:embed="rId7"/>
-                </a:ext>
-              </a:extLst>
-            </a:blip>
-            <a:stretch>
-              <a:fillRect l="0" t="0" r="0" b="0"/>
-            </a:stretch>
-          </a:blipFill>
-        </p:spPr>
-        <p:txBody>
-          <a:bodyPr/>
-          <a:p/>
-        </p:txBody>
-      </p:sp>
-      <p:sp>
-        <p:nvSpPr>
           <p:cNvPr name="Freeform 6" id="6"/>
           <p:cNvSpPr/>
           <p:nvPr/>
@@ -11465,159 +9584,6 @@
             </a:blip>
             <a:stretch>
               <a:fillRect l="0" t="0" r="0" b="0"/>
-            </a:stretch>
-          </a:blipFill>
-        </p:spPr>
-        <p:txBody>
-          <a:bodyPr/>
-          <a:p/>
-        </p:txBody>
-      </p:sp>
-      <p:sp>
-        <p:nvSpPr>
-          <p:cNvPr name="Freeform 8" id="8"/>
-          <p:cNvSpPr/>
-          <p:nvPr/>
-        </p:nvSpPr>
-        <p:spPr>
-          <a:xfrm flipH="false" flipV="false" rot="0">
-            <a:off x="1032684" y="1037874"/>
-            <a:ext cx="432986" cy="585638"/>
-          </a:xfrm>
-          <a:custGeom>
-            <a:avLst/>
-            <a:gdLst/>
-            <a:ahLst/>
-            <a:cxnLst/>
-            <a:rect r="r" b="b" t="t" l="l"/>
-            <a:pathLst>
-              <a:path h="585638" w="432986">
-                <a:moveTo>
-                  <a:pt x="0" y="0"/>
-                </a:moveTo>
-                <a:lnTo>
-                  <a:pt x="432987" y="0"/>
-                </a:lnTo>
-                <a:lnTo>
-                  <a:pt x="432987" y="585638"/>
-                </a:lnTo>
-                <a:lnTo>
-                  <a:pt x="0" y="585638"/>
-                </a:lnTo>
-                <a:lnTo>
-                  <a:pt x="0" y="0"/>
-                </a:lnTo>
-                <a:close/>
-              </a:path>
-            </a:pathLst>
-          </a:custGeom>
-          <a:blipFill>
-            <a:blip r:embed="rId10">
-              <a:extLst>
-                <a:ext uri="{96DAC541-7B7A-43D3-8B79-37D633B846F1}">
-                  <asvg:svgBlip xmlns:asvg="http://schemas.microsoft.com/office/drawing/2016/SVG/main" r:embed="rId11"/>
-                </a:ext>
-              </a:extLst>
-            </a:blip>
-            <a:stretch>
-              <a:fillRect l="0" t="0" r="-21157" b="-4158"/>
-            </a:stretch>
-          </a:blipFill>
-        </p:spPr>
-        <p:txBody>
-          <a:bodyPr/>
-          <a:p/>
-        </p:txBody>
-      </p:sp>
-      <p:sp>
-        <p:nvSpPr>
-          <p:cNvPr name="TextBox 9" id="9"/>
-          <p:cNvSpPr txBox="true"/>
-          <p:nvPr/>
-        </p:nvSpPr>
-        <p:spPr>
-          <a:xfrm rot="0">
-            <a:off x="1268082" y="1198060"/>
-            <a:ext cx="1535820" cy="266699"/>
-          </a:xfrm>
-          <a:prstGeom prst="rect">
-            <a:avLst/>
-          </a:prstGeom>
-        </p:spPr>
-        <p:txBody>
-          <a:bodyPr anchor="t" rtlCol="false" tIns="0" lIns="0" bIns="0" rIns="0">
-            <a:spAutoFit/>
-          </a:bodyPr>
-          <a:lstStyle/>
-          <a:p>
-            <a:pPr algn="l">
-              <a:lnSpc>
-                <a:spcPts val="2100"/>
-              </a:lnSpc>
-            </a:pPr>
-            <a:r>
-              <a:rPr lang="en-US" sz="1500" b="true">
-                <a:solidFill>
-                  <a:srgbClr val="042147"/>
-                </a:solidFill>
-                <a:latin typeface="Cormorant Garamond Bold"/>
-                <a:ea typeface="Cormorant Garamond Bold"/>
-                <a:cs typeface="Cormorant Garamond Bold"/>
-                <a:sym typeface="Cormorant Garamond Bold"/>
-              </a:rPr>
-              <a:t/>
-            </a:r>
-          </a:p>
-        </p:txBody>
-      </p:sp>
-      <p:sp>
-        <p:nvSpPr>
-          <p:cNvPr name="Freeform 10" id="10"/>
-          <p:cNvSpPr/>
-          <p:nvPr/>
-        </p:nvSpPr>
-        <p:spPr>
-          <a:xfrm flipH="false" flipV="false" rot="0">
-            <a:off x="1032684" y="1050223"/>
-            <a:ext cx="474326" cy="588321"/>
-          </a:xfrm>
-          <a:custGeom>
-            <a:avLst/>
-            <a:gdLst/>
-            <a:ahLst/>
-            <a:cxnLst/>
-            <a:rect r="r" b="b" t="t" l="l"/>
-            <a:pathLst>
-              <a:path h="588321" w="474326">
-                <a:moveTo>
-                  <a:pt x="0" y="0"/>
-                </a:moveTo>
-                <a:lnTo>
-                  <a:pt x="474326" y="0"/>
-                </a:lnTo>
-                <a:lnTo>
-                  <a:pt x="474326" y="588322"/>
-                </a:lnTo>
-                <a:lnTo>
-                  <a:pt x="0" y="588322"/>
-                </a:lnTo>
-                <a:lnTo>
-                  <a:pt x="0" y="0"/>
-                </a:lnTo>
-                <a:close/>
-              </a:path>
-            </a:pathLst>
-          </a:custGeom>
-          <a:blipFill>
-            <a:blip r:embed="rId10">
-              <a:extLst>
-                <a:ext uri="{96DAC541-7B7A-43D3-8B79-37D633B846F1}">
-                  <asvg:svgBlip xmlns:asvg="http://schemas.microsoft.com/office/drawing/2016/SVG/main" r:embed="rId11"/>
-                </a:ext>
-              </a:extLst>
-            </a:blip>
-            <a:stretch>
-              <a:fillRect l="0" t="-2099" r="-10598" b="-1584"/>
             </a:stretch>
           </a:blipFill>
         </p:spPr>
@@ -12060,62 +10026,6 @@
       </p:sp>
       <p:sp>
         <p:nvSpPr>
-          <p:cNvPr name="Freeform 5" id="5"/>
-          <p:cNvSpPr/>
-          <p:nvPr/>
-        </p:nvSpPr>
-        <p:spPr>
-          <a:xfrm flipH="false" flipV="false" rot="0">
-            <a:off x="15811736" y="736129"/>
-            <a:ext cx="1447564" cy="628188"/>
-          </a:xfrm>
-          <a:custGeom>
-            <a:avLst/>
-            <a:gdLst/>
-            <a:ahLst/>
-            <a:cxnLst/>
-            <a:rect r="r" b="b" t="t" l="l"/>
-            <a:pathLst>
-              <a:path h="628188" w="1447564">
-                <a:moveTo>
-                  <a:pt x="0" y="0"/>
-                </a:moveTo>
-                <a:lnTo>
-                  <a:pt x="1447564" y="0"/>
-                </a:lnTo>
-                <a:lnTo>
-                  <a:pt x="1447564" y="628188"/>
-                </a:lnTo>
-                <a:lnTo>
-                  <a:pt x="0" y="628188"/>
-                </a:lnTo>
-                <a:lnTo>
-                  <a:pt x="0" y="0"/>
-                </a:lnTo>
-                <a:close/>
-              </a:path>
-            </a:pathLst>
-          </a:custGeom>
-          <a:blipFill>
-            <a:blip r:embed="rId6">
-              <a:extLst>
-                <a:ext uri="{96DAC541-7B7A-43D3-8B79-37D633B846F1}">
-                  <asvg:svgBlip xmlns:asvg="http://schemas.microsoft.com/office/drawing/2016/SVG/main" r:embed="rId7"/>
-                </a:ext>
-              </a:extLst>
-            </a:blip>
-            <a:stretch>
-              <a:fillRect l="0" t="0" r="0" b="0"/>
-            </a:stretch>
-          </a:blipFill>
-        </p:spPr>
-        <p:txBody>
-          <a:bodyPr/>
-          <a:p/>
-        </p:txBody>
-      </p:sp>
-      <p:sp>
-        <p:nvSpPr>
           <p:cNvPr name="Freeform 6" id="6"/>
           <p:cNvSpPr/>
           <p:nvPr/>
@@ -12219,159 +10129,6 @@
             </a:blip>
             <a:stretch>
               <a:fillRect l="0" t="0" r="0" b="0"/>
-            </a:stretch>
-          </a:blipFill>
-        </p:spPr>
-        <p:txBody>
-          <a:bodyPr/>
-          <a:p/>
-        </p:txBody>
-      </p:sp>
-      <p:sp>
-        <p:nvSpPr>
-          <p:cNvPr name="Freeform 8" id="8"/>
-          <p:cNvSpPr/>
-          <p:nvPr/>
-        </p:nvSpPr>
-        <p:spPr>
-          <a:xfrm flipH="false" flipV="false" rot="0">
-            <a:off x="1032684" y="1037874"/>
-            <a:ext cx="432986" cy="585638"/>
-          </a:xfrm>
-          <a:custGeom>
-            <a:avLst/>
-            <a:gdLst/>
-            <a:ahLst/>
-            <a:cxnLst/>
-            <a:rect r="r" b="b" t="t" l="l"/>
-            <a:pathLst>
-              <a:path h="585638" w="432986">
-                <a:moveTo>
-                  <a:pt x="0" y="0"/>
-                </a:moveTo>
-                <a:lnTo>
-                  <a:pt x="432987" y="0"/>
-                </a:lnTo>
-                <a:lnTo>
-                  <a:pt x="432987" y="585638"/>
-                </a:lnTo>
-                <a:lnTo>
-                  <a:pt x="0" y="585638"/>
-                </a:lnTo>
-                <a:lnTo>
-                  <a:pt x="0" y="0"/>
-                </a:lnTo>
-                <a:close/>
-              </a:path>
-            </a:pathLst>
-          </a:custGeom>
-          <a:blipFill>
-            <a:blip r:embed="rId10">
-              <a:extLst>
-                <a:ext uri="{96DAC541-7B7A-43D3-8B79-37D633B846F1}">
-                  <asvg:svgBlip xmlns:asvg="http://schemas.microsoft.com/office/drawing/2016/SVG/main" r:embed="rId11"/>
-                </a:ext>
-              </a:extLst>
-            </a:blip>
-            <a:stretch>
-              <a:fillRect l="0" t="0" r="-21157" b="-4158"/>
-            </a:stretch>
-          </a:blipFill>
-        </p:spPr>
-        <p:txBody>
-          <a:bodyPr/>
-          <a:p/>
-        </p:txBody>
-      </p:sp>
-      <p:sp>
-        <p:nvSpPr>
-          <p:cNvPr name="TextBox 9" id="9"/>
-          <p:cNvSpPr txBox="true"/>
-          <p:nvPr/>
-        </p:nvSpPr>
-        <p:spPr>
-          <a:xfrm rot="0">
-            <a:off x="1268082" y="1198060"/>
-            <a:ext cx="1535820" cy="266699"/>
-          </a:xfrm>
-          <a:prstGeom prst="rect">
-            <a:avLst/>
-          </a:prstGeom>
-        </p:spPr>
-        <p:txBody>
-          <a:bodyPr anchor="t" rtlCol="false" tIns="0" lIns="0" bIns="0" rIns="0">
-            <a:spAutoFit/>
-          </a:bodyPr>
-          <a:lstStyle/>
-          <a:p>
-            <a:pPr algn="l">
-              <a:lnSpc>
-                <a:spcPts val="2100"/>
-              </a:lnSpc>
-            </a:pPr>
-            <a:r>
-              <a:rPr lang="en-US" sz="1500" b="true">
-                <a:solidFill>
-                  <a:srgbClr val="042147"/>
-                </a:solidFill>
-                <a:latin typeface="Cormorant Garamond Bold"/>
-                <a:ea typeface="Cormorant Garamond Bold"/>
-                <a:cs typeface="Cormorant Garamond Bold"/>
-                <a:sym typeface="Cormorant Garamond Bold"/>
-              </a:rPr>
-              <a:t/>
-            </a:r>
-          </a:p>
-        </p:txBody>
-      </p:sp>
-      <p:sp>
-        <p:nvSpPr>
-          <p:cNvPr name="Freeform 10" id="10"/>
-          <p:cNvSpPr/>
-          <p:nvPr/>
-        </p:nvSpPr>
-        <p:spPr>
-          <a:xfrm flipH="false" flipV="false" rot="0">
-            <a:off x="1032684" y="1050223"/>
-            <a:ext cx="474326" cy="588321"/>
-          </a:xfrm>
-          <a:custGeom>
-            <a:avLst/>
-            <a:gdLst/>
-            <a:ahLst/>
-            <a:cxnLst/>
-            <a:rect r="r" b="b" t="t" l="l"/>
-            <a:pathLst>
-              <a:path h="588321" w="474326">
-                <a:moveTo>
-                  <a:pt x="0" y="0"/>
-                </a:moveTo>
-                <a:lnTo>
-                  <a:pt x="474326" y="0"/>
-                </a:lnTo>
-                <a:lnTo>
-                  <a:pt x="474326" y="588322"/>
-                </a:lnTo>
-                <a:lnTo>
-                  <a:pt x="0" y="588322"/>
-                </a:lnTo>
-                <a:lnTo>
-                  <a:pt x="0" y="0"/>
-                </a:lnTo>
-                <a:close/>
-              </a:path>
-            </a:pathLst>
-          </a:custGeom>
-          <a:blipFill>
-            <a:blip r:embed="rId10">
-              <a:extLst>
-                <a:ext uri="{96DAC541-7B7A-43D3-8B79-37D633B846F1}">
-                  <asvg:svgBlip xmlns:asvg="http://schemas.microsoft.com/office/drawing/2016/SVG/main" r:embed="rId11"/>
-                </a:ext>
-              </a:extLst>
-            </a:blip>
-            <a:stretch>
-              <a:fillRect l="0" t="-2099" r="-10598" b="-1584"/>
             </a:stretch>
           </a:blipFill>
         </p:spPr>
@@ -12873,62 +10630,6 @@
       </p:sp>
       <p:sp>
         <p:nvSpPr>
-          <p:cNvPr name="Freeform 5" id="5"/>
-          <p:cNvSpPr/>
-          <p:nvPr/>
-        </p:nvSpPr>
-        <p:spPr>
-          <a:xfrm flipH="false" flipV="false" rot="0">
-            <a:off x="14134123" y="8944206"/>
-            <a:ext cx="1447564" cy="628188"/>
-          </a:xfrm>
-          <a:custGeom>
-            <a:avLst/>
-            <a:gdLst/>
-            <a:ahLst/>
-            <a:cxnLst/>
-            <a:rect r="r" b="b" t="t" l="l"/>
-            <a:pathLst>
-              <a:path h="628188" w="1447564">
-                <a:moveTo>
-                  <a:pt x="0" y="0"/>
-                </a:moveTo>
-                <a:lnTo>
-                  <a:pt x="1447564" y="0"/>
-                </a:lnTo>
-                <a:lnTo>
-                  <a:pt x="1447564" y="628188"/>
-                </a:lnTo>
-                <a:lnTo>
-                  <a:pt x="0" y="628188"/>
-                </a:lnTo>
-                <a:lnTo>
-                  <a:pt x="0" y="0"/>
-                </a:lnTo>
-                <a:close/>
-              </a:path>
-            </a:pathLst>
-          </a:custGeom>
-          <a:blipFill>
-            <a:blip r:embed="rId6">
-              <a:extLst>
-                <a:ext uri="{96DAC541-7B7A-43D3-8B79-37D633B846F1}">
-                  <asvg:svgBlip xmlns:asvg="http://schemas.microsoft.com/office/drawing/2016/SVG/main" r:embed="rId7"/>
-                </a:ext>
-              </a:extLst>
-            </a:blip>
-            <a:stretch>
-              <a:fillRect l="0" t="0" r="0" b="0"/>
-            </a:stretch>
-          </a:blipFill>
-        </p:spPr>
-        <p:txBody>
-          <a:bodyPr/>
-          <a:p/>
-        </p:txBody>
-      </p:sp>
-      <p:sp>
-        <p:nvSpPr>
           <p:cNvPr name="Freeform 6" id="6"/>
           <p:cNvSpPr/>
           <p:nvPr/>
@@ -13032,159 +10733,6 @@
             </a:blip>
             <a:stretch>
               <a:fillRect l="0" t="0" r="0" b="0"/>
-            </a:stretch>
-          </a:blipFill>
-        </p:spPr>
-        <p:txBody>
-          <a:bodyPr/>
-          <a:p/>
-        </p:txBody>
-      </p:sp>
-      <p:sp>
-        <p:nvSpPr>
-          <p:cNvPr name="Freeform 8" id="8"/>
-          <p:cNvSpPr/>
-          <p:nvPr/>
-        </p:nvSpPr>
-        <p:spPr>
-          <a:xfrm flipH="false" flipV="false" rot="0">
-            <a:off x="1032684" y="1037874"/>
-            <a:ext cx="432986" cy="585638"/>
-          </a:xfrm>
-          <a:custGeom>
-            <a:avLst/>
-            <a:gdLst/>
-            <a:ahLst/>
-            <a:cxnLst/>
-            <a:rect r="r" b="b" t="t" l="l"/>
-            <a:pathLst>
-              <a:path h="585638" w="432986">
-                <a:moveTo>
-                  <a:pt x="0" y="0"/>
-                </a:moveTo>
-                <a:lnTo>
-                  <a:pt x="432987" y="0"/>
-                </a:lnTo>
-                <a:lnTo>
-                  <a:pt x="432987" y="585638"/>
-                </a:lnTo>
-                <a:lnTo>
-                  <a:pt x="0" y="585638"/>
-                </a:lnTo>
-                <a:lnTo>
-                  <a:pt x="0" y="0"/>
-                </a:lnTo>
-                <a:close/>
-              </a:path>
-            </a:pathLst>
-          </a:custGeom>
-          <a:blipFill>
-            <a:blip r:embed="rId8">
-              <a:extLst>
-                <a:ext uri="{96DAC541-7B7A-43D3-8B79-37D633B846F1}">
-                  <asvg:svgBlip xmlns:asvg="http://schemas.microsoft.com/office/drawing/2016/SVG/main" r:embed="rId9"/>
-                </a:ext>
-              </a:extLst>
-            </a:blip>
-            <a:stretch>
-              <a:fillRect l="0" t="0" r="-21157" b="-4158"/>
-            </a:stretch>
-          </a:blipFill>
-        </p:spPr>
-        <p:txBody>
-          <a:bodyPr/>
-          <a:p/>
-        </p:txBody>
-      </p:sp>
-      <p:sp>
-        <p:nvSpPr>
-          <p:cNvPr name="TextBox 9" id="9"/>
-          <p:cNvSpPr txBox="true"/>
-          <p:nvPr/>
-        </p:nvSpPr>
-        <p:spPr>
-          <a:xfrm rot="0">
-            <a:off x="1268082" y="1198060"/>
-            <a:ext cx="1535820" cy="266699"/>
-          </a:xfrm>
-          <a:prstGeom prst="rect">
-            <a:avLst/>
-          </a:prstGeom>
-        </p:spPr>
-        <p:txBody>
-          <a:bodyPr anchor="t" rtlCol="false" tIns="0" lIns="0" bIns="0" rIns="0">
-            <a:spAutoFit/>
-          </a:bodyPr>
-          <a:lstStyle/>
-          <a:p>
-            <a:pPr algn="l">
-              <a:lnSpc>
-                <a:spcPts val="2100"/>
-              </a:lnSpc>
-            </a:pPr>
-            <a:r>
-              <a:rPr lang="en-US" sz="1500" b="true">
-                <a:solidFill>
-                  <a:srgbClr val="042147"/>
-                </a:solidFill>
-                <a:latin typeface="Cormorant Garamond Bold"/>
-                <a:ea typeface="Cormorant Garamond Bold"/>
-                <a:cs typeface="Cormorant Garamond Bold"/>
-                <a:sym typeface="Cormorant Garamond Bold"/>
-              </a:rPr>
-              <a:t/>
-            </a:r>
-          </a:p>
-        </p:txBody>
-      </p:sp>
-      <p:sp>
-        <p:nvSpPr>
-          <p:cNvPr name="Freeform 10" id="10"/>
-          <p:cNvSpPr/>
-          <p:nvPr/>
-        </p:nvSpPr>
-        <p:spPr>
-          <a:xfrm flipH="false" flipV="false" rot="0">
-            <a:off x="1032684" y="1050223"/>
-            <a:ext cx="474326" cy="588321"/>
-          </a:xfrm>
-          <a:custGeom>
-            <a:avLst/>
-            <a:gdLst/>
-            <a:ahLst/>
-            <a:cxnLst/>
-            <a:rect r="r" b="b" t="t" l="l"/>
-            <a:pathLst>
-              <a:path h="588321" w="474326">
-                <a:moveTo>
-                  <a:pt x="0" y="0"/>
-                </a:moveTo>
-                <a:lnTo>
-                  <a:pt x="474326" y="0"/>
-                </a:lnTo>
-                <a:lnTo>
-                  <a:pt x="474326" y="588322"/>
-                </a:lnTo>
-                <a:lnTo>
-                  <a:pt x="0" y="588322"/>
-                </a:lnTo>
-                <a:lnTo>
-                  <a:pt x="0" y="0"/>
-                </a:lnTo>
-                <a:close/>
-              </a:path>
-            </a:pathLst>
-          </a:custGeom>
-          <a:blipFill>
-            <a:blip r:embed="rId8">
-              <a:extLst>
-                <a:ext uri="{96DAC541-7B7A-43D3-8B79-37D633B846F1}">
-                  <asvg:svgBlip xmlns:asvg="http://schemas.microsoft.com/office/drawing/2016/SVG/main" r:embed="rId9"/>
-                </a:ext>
-              </a:extLst>
-            </a:blip>
-            <a:stretch>
-              <a:fillRect l="0" t="-2099" r="-10598" b="-1584"/>
             </a:stretch>
           </a:blipFill>
         </p:spPr>
@@ -13562,62 +11110,6 @@
       </p:sp>
       <p:sp>
         <p:nvSpPr>
-          <p:cNvPr name="Freeform 5" id="5"/>
-          <p:cNvSpPr/>
-          <p:nvPr/>
-        </p:nvSpPr>
-        <p:spPr>
-          <a:xfrm flipH="false" flipV="false" rot="-5400000">
-            <a:off x="16535518" y="3806048"/>
-            <a:ext cx="1447564" cy="628188"/>
-          </a:xfrm>
-          <a:custGeom>
-            <a:avLst/>
-            <a:gdLst/>
-            <a:ahLst/>
-            <a:cxnLst/>
-            <a:rect r="r" b="b" t="t" l="l"/>
-            <a:pathLst>
-              <a:path h="628188" w="1447564">
-                <a:moveTo>
-                  <a:pt x="0" y="0"/>
-                </a:moveTo>
-                <a:lnTo>
-                  <a:pt x="1447564" y="0"/>
-                </a:lnTo>
-                <a:lnTo>
-                  <a:pt x="1447564" y="628188"/>
-                </a:lnTo>
-                <a:lnTo>
-                  <a:pt x="0" y="628188"/>
-                </a:lnTo>
-                <a:lnTo>
-                  <a:pt x="0" y="0"/>
-                </a:lnTo>
-                <a:close/>
-              </a:path>
-            </a:pathLst>
-          </a:custGeom>
-          <a:blipFill>
-            <a:blip r:embed="rId6">
-              <a:extLst>
-                <a:ext uri="{96DAC541-7B7A-43D3-8B79-37D633B846F1}">
-                  <asvg:svgBlip xmlns:asvg="http://schemas.microsoft.com/office/drawing/2016/SVG/main" r:embed="rId7"/>
-                </a:ext>
-              </a:extLst>
-            </a:blip>
-            <a:stretch>
-              <a:fillRect l="0" t="0" r="0" b="0"/>
-            </a:stretch>
-          </a:blipFill>
-        </p:spPr>
-        <p:txBody>
-          <a:bodyPr/>
-          <a:p/>
-        </p:txBody>
-      </p:sp>
-      <p:sp>
-        <p:nvSpPr>
           <p:cNvPr name="Freeform 6" id="6"/>
           <p:cNvSpPr/>
           <p:nvPr/>
@@ -13665,159 +11157,6 @@
             </a:blip>
             <a:stretch>
               <a:fillRect l="0" t="0" r="0" b="0"/>
-            </a:stretch>
-          </a:blipFill>
-        </p:spPr>
-        <p:txBody>
-          <a:bodyPr/>
-          <a:p/>
-        </p:txBody>
-      </p:sp>
-      <p:sp>
-        <p:nvSpPr>
-          <p:cNvPr name="Freeform 7" id="7"/>
-          <p:cNvSpPr/>
-          <p:nvPr/>
-        </p:nvSpPr>
-        <p:spPr>
-          <a:xfrm flipH="false" flipV="false" rot="0">
-            <a:off x="1032684" y="1037874"/>
-            <a:ext cx="432986" cy="585638"/>
-          </a:xfrm>
-          <a:custGeom>
-            <a:avLst/>
-            <a:gdLst/>
-            <a:ahLst/>
-            <a:cxnLst/>
-            <a:rect r="r" b="b" t="t" l="l"/>
-            <a:pathLst>
-              <a:path h="585638" w="432986">
-                <a:moveTo>
-                  <a:pt x="0" y="0"/>
-                </a:moveTo>
-                <a:lnTo>
-                  <a:pt x="432987" y="0"/>
-                </a:lnTo>
-                <a:lnTo>
-                  <a:pt x="432987" y="585638"/>
-                </a:lnTo>
-                <a:lnTo>
-                  <a:pt x="0" y="585638"/>
-                </a:lnTo>
-                <a:lnTo>
-                  <a:pt x="0" y="0"/>
-                </a:lnTo>
-                <a:close/>
-              </a:path>
-            </a:pathLst>
-          </a:custGeom>
-          <a:blipFill>
-            <a:blip r:embed="rId8">
-              <a:extLst>
-                <a:ext uri="{96DAC541-7B7A-43D3-8B79-37D633B846F1}">
-                  <asvg:svgBlip xmlns:asvg="http://schemas.microsoft.com/office/drawing/2016/SVG/main" r:embed="rId9"/>
-                </a:ext>
-              </a:extLst>
-            </a:blip>
-            <a:stretch>
-              <a:fillRect l="0" t="0" r="-21157" b="-4158"/>
-            </a:stretch>
-          </a:blipFill>
-        </p:spPr>
-        <p:txBody>
-          <a:bodyPr/>
-          <a:p/>
-        </p:txBody>
-      </p:sp>
-      <p:sp>
-        <p:nvSpPr>
-          <p:cNvPr name="TextBox 8" id="8"/>
-          <p:cNvSpPr txBox="true"/>
-          <p:nvPr/>
-        </p:nvSpPr>
-        <p:spPr>
-          <a:xfrm rot="0">
-            <a:off x="1268082" y="1198060"/>
-            <a:ext cx="1535820" cy="266699"/>
-          </a:xfrm>
-          <a:prstGeom prst="rect">
-            <a:avLst/>
-          </a:prstGeom>
-        </p:spPr>
-        <p:txBody>
-          <a:bodyPr anchor="t" rtlCol="false" tIns="0" lIns="0" bIns="0" rIns="0">
-            <a:spAutoFit/>
-          </a:bodyPr>
-          <a:lstStyle/>
-          <a:p>
-            <a:pPr algn="l">
-              <a:lnSpc>
-                <a:spcPts val="2100"/>
-              </a:lnSpc>
-            </a:pPr>
-            <a:r>
-              <a:rPr lang="en-US" sz="1500" b="true">
-                <a:solidFill>
-                  <a:srgbClr val="042147"/>
-                </a:solidFill>
-                <a:latin typeface="Cormorant Garamond Bold"/>
-                <a:ea typeface="Cormorant Garamond Bold"/>
-                <a:cs typeface="Cormorant Garamond Bold"/>
-                <a:sym typeface="Cormorant Garamond Bold"/>
-              </a:rPr>
-              <a:t/>
-            </a:r>
-          </a:p>
-        </p:txBody>
-      </p:sp>
-      <p:sp>
-        <p:nvSpPr>
-          <p:cNvPr name="Freeform 9" id="9"/>
-          <p:cNvSpPr/>
-          <p:nvPr/>
-        </p:nvSpPr>
-        <p:spPr>
-          <a:xfrm flipH="false" flipV="false" rot="0">
-            <a:off x="1032684" y="1050223"/>
-            <a:ext cx="474326" cy="588321"/>
-          </a:xfrm>
-          <a:custGeom>
-            <a:avLst/>
-            <a:gdLst/>
-            <a:ahLst/>
-            <a:cxnLst/>
-            <a:rect r="r" b="b" t="t" l="l"/>
-            <a:pathLst>
-              <a:path h="588321" w="474326">
-                <a:moveTo>
-                  <a:pt x="0" y="0"/>
-                </a:moveTo>
-                <a:lnTo>
-                  <a:pt x="474326" y="0"/>
-                </a:lnTo>
-                <a:lnTo>
-                  <a:pt x="474326" y="588322"/>
-                </a:lnTo>
-                <a:lnTo>
-                  <a:pt x="0" y="588322"/>
-                </a:lnTo>
-                <a:lnTo>
-                  <a:pt x="0" y="0"/>
-                </a:lnTo>
-                <a:close/>
-              </a:path>
-            </a:pathLst>
-          </a:custGeom>
-          <a:blipFill>
-            <a:blip r:embed="rId8">
-              <a:extLst>
-                <a:ext uri="{96DAC541-7B7A-43D3-8B79-37D633B846F1}">
-                  <asvg:svgBlip xmlns:asvg="http://schemas.microsoft.com/office/drawing/2016/SVG/main" r:embed="rId9"/>
-                </a:ext>
-              </a:extLst>
-            </a:blip>
-            <a:stretch>
-              <a:fillRect l="0" t="-2099" r="-10598" b="-1584"/>
             </a:stretch>
           </a:blipFill>
         </p:spPr>

</xml_diff>

<commit_message>
feat(internship-3): add real Union Bank of India logo to all slides
The generic template ring icon I removed earlier was standing in
that corner slot; the actual UBO.jpeg logo (found in this folder)
now sits there on all 13 slides instead, no overlap with any title.

Co-Authored-By: Claude Sonnet 5 <noreply@anthropic.com>
</commit_message>
<xml_diff>
--- a/306 - Internship 3/Internship 3 v2.pptx
+++ b/306 - Internship 3/Internship 3 v2.pptx
@@ -3616,6 +3616,30 @@
           <a:p/>
         </p:txBody>
       </p:sp>
+      <p:pic>
+        <p:nvPicPr>
+          <p:cNvPr id="18" name="Picture 17" descr="UBO.jpeg"/>
+          <p:cNvPicPr>
+            <a:picLocks noChangeAspect="1"/>
+          </p:cNvPicPr>
+          <p:nvPr/>
+        </p:nvPicPr>
+        <p:blipFill>
+          <a:blip r:embed="rId12"/>
+          <a:stretch>
+            <a:fillRect/>
+          </a:stretch>
+        </p:blipFill>
+        <p:spPr>
+          <a:xfrm>
+            <a:off x="950000" y="950000"/>
+            <a:ext cx="777240" cy="777240"/>
+          </a:xfrm>
+          <a:prstGeom prst="rect">
+            <a:avLst/>
+          </a:prstGeom>
+        </p:spPr>
+      </p:pic>
     </p:spTree>
   </p:cSld>
   <p:clrMapOvr>
@@ -4192,6 +4216,30 @@
           </p:txBody>
         </p:sp>
       </p:grpSp>
+      <p:pic>
+        <p:nvPicPr>
+          <p:cNvPr id="18" name="Picture 17" descr="UBO.jpeg"/>
+          <p:cNvPicPr>
+            <a:picLocks noChangeAspect="1"/>
+          </p:cNvPicPr>
+          <p:nvPr/>
+        </p:nvPicPr>
+        <p:blipFill>
+          <a:blip r:embed="rId12"/>
+          <a:stretch>
+            <a:fillRect/>
+          </a:stretch>
+        </p:blipFill>
+        <p:spPr>
+          <a:xfrm>
+            <a:off x="950000" y="950000"/>
+            <a:ext cx="777240" cy="777240"/>
+          </a:xfrm>
+          <a:prstGeom prst="rect">
+            <a:avLst/>
+          </a:prstGeom>
+        </p:spPr>
+      </p:pic>
     </p:spTree>
   </p:cSld>
   <p:clrMapOvr>
@@ -4696,6 +4744,30 @@
           </a:p>
         </p:txBody>
       </p:sp>
+      <p:pic>
+        <p:nvPicPr>
+          <p:cNvPr id="15" name="Picture 14" descr="UBO.jpeg"/>
+          <p:cNvPicPr>
+            <a:picLocks noChangeAspect="1"/>
+          </p:cNvPicPr>
+          <p:nvPr/>
+        </p:nvPicPr>
+        <p:blipFill>
+          <a:blip r:embed="rId12"/>
+          <a:stretch>
+            <a:fillRect/>
+          </a:stretch>
+        </p:blipFill>
+        <p:spPr>
+          <a:xfrm>
+            <a:off x="950000" y="950000"/>
+            <a:ext cx="777240" cy="777240"/>
+          </a:xfrm>
+          <a:prstGeom prst="rect">
+            <a:avLst/>
+          </a:prstGeom>
+        </p:spPr>
+      </p:pic>
     </p:spTree>
   </p:cSld>
   <p:clrMapOvr>
@@ -6056,6 +6128,30 @@
           </a:p>
         </p:txBody>
       </p:sp>
+      <p:pic>
+        <p:nvPicPr>
+          <p:cNvPr id="31" name="Picture 30" descr="UBO.jpeg"/>
+          <p:cNvPicPr>
+            <a:picLocks noChangeAspect="1"/>
+          </p:cNvPicPr>
+          <p:nvPr/>
+        </p:nvPicPr>
+        <p:blipFill>
+          <a:blip r:embed="rId22"/>
+          <a:stretch>
+            <a:fillRect/>
+          </a:stretch>
+        </p:blipFill>
+        <p:spPr>
+          <a:xfrm>
+            <a:off x="950000" y="950000"/>
+            <a:ext cx="777240" cy="777240"/>
+          </a:xfrm>
+          <a:prstGeom prst="rect">
+            <a:avLst/>
+          </a:prstGeom>
+        </p:spPr>
+      </p:pic>
     </p:spTree>
   </p:cSld>
   <p:clrMapOvr>
@@ -6339,6 +6435,30 @@
           </a:p>
         </p:txBody>
       </p:sp>
+      <p:pic>
+        <p:nvPicPr>
+          <p:cNvPr id="11" name="Picture 10" descr="UBO.jpeg"/>
+          <p:cNvPicPr>
+            <a:picLocks noChangeAspect="1"/>
+          </p:cNvPicPr>
+          <p:nvPr/>
+        </p:nvPicPr>
+        <p:blipFill>
+          <a:blip r:embed="rId12"/>
+          <a:stretch>
+            <a:fillRect/>
+          </a:stretch>
+        </p:blipFill>
+        <p:spPr>
+          <a:xfrm>
+            <a:off x="950000" y="950000"/>
+            <a:ext cx="777240" cy="777240"/>
+          </a:xfrm>
+          <a:prstGeom prst="rect">
+            <a:avLst/>
+          </a:prstGeom>
+        </p:spPr>
+      </p:pic>
     </p:spTree>
   </p:cSld>
   <p:clrMapOvr>
@@ -7055,6 +7175,30 @@
           </a:p>
         </p:txBody>
       </p:sp>
+      <p:pic>
+        <p:nvPicPr>
+          <p:cNvPr id="19" name="Picture 18" descr="UBO.jpeg"/>
+          <p:cNvPicPr>
+            <a:picLocks noChangeAspect="1"/>
+          </p:cNvPicPr>
+          <p:nvPr/>
+        </p:nvPicPr>
+        <p:blipFill>
+          <a:blip r:embed="rId20"/>
+          <a:stretch>
+            <a:fillRect/>
+          </a:stretch>
+        </p:blipFill>
+        <p:spPr>
+          <a:xfrm>
+            <a:off x="950000" y="950000"/>
+            <a:ext cx="777240" cy="777240"/>
+          </a:xfrm>
+          <a:prstGeom prst="rect">
+            <a:avLst/>
+          </a:prstGeom>
+        </p:spPr>
+      </p:pic>
     </p:spTree>
   </p:cSld>
   <p:clrMapOvr>
@@ -7535,6 +7679,30 @@
           </a:p>
         </p:txBody>
       </p:sp>
+      <p:pic>
+        <p:nvPicPr>
+          <p:cNvPr id="15" name="Picture 14" descr="UBO.jpeg"/>
+          <p:cNvPicPr>
+            <a:picLocks noChangeAspect="1"/>
+          </p:cNvPicPr>
+          <p:nvPr/>
+        </p:nvPicPr>
+        <p:blipFill>
+          <a:blip r:embed="rId12"/>
+          <a:stretch>
+            <a:fillRect/>
+          </a:stretch>
+        </p:blipFill>
+        <p:spPr>
+          <a:xfrm>
+            <a:off x="950000" y="950000"/>
+            <a:ext cx="777240" cy="777240"/>
+          </a:xfrm>
+          <a:prstGeom prst="rect">
+            <a:avLst/>
+          </a:prstGeom>
+        </p:spPr>
+      </p:pic>
     </p:spTree>
   </p:cSld>
   <p:clrMapOvr>
@@ -8111,6 +8279,30 @@
           </p:txBody>
         </p:sp>
       </p:grpSp>
+      <p:pic>
+        <p:nvPicPr>
+          <p:cNvPr id="18" name="Picture 17" descr="UBO.jpeg"/>
+          <p:cNvPicPr>
+            <a:picLocks noChangeAspect="1"/>
+          </p:cNvPicPr>
+          <p:nvPr/>
+        </p:nvPicPr>
+        <p:blipFill>
+          <a:blip r:embed="rId12"/>
+          <a:stretch>
+            <a:fillRect/>
+          </a:stretch>
+        </p:blipFill>
+        <p:spPr>
+          <a:xfrm>
+            <a:off x="950000" y="950000"/>
+            <a:ext cx="777240" cy="777240"/>
+          </a:xfrm>
+          <a:prstGeom prst="rect">
+            <a:avLst/>
+          </a:prstGeom>
+        </p:spPr>
+      </p:pic>
     </p:spTree>
   </p:cSld>
   <p:clrMapOvr>
@@ -9300,6 +9492,30 @@
           </a:p>
         </p:txBody>
       </p:sp>
+      <p:pic>
+        <p:nvPicPr>
+          <p:cNvPr id="35" name="Picture 34" descr="UBO.jpeg"/>
+          <p:cNvPicPr>
+            <a:picLocks noChangeAspect="1"/>
+          </p:cNvPicPr>
+          <p:nvPr/>
+        </p:nvPicPr>
+        <p:blipFill>
+          <a:blip r:embed="rId22"/>
+          <a:stretch>
+            <a:fillRect/>
+          </a:stretch>
+        </p:blipFill>
+        <p:spPr>
+          <a:xfrm>
+            <a:off x="950000" y="950000"/>
+            <a:ext cx="777240" cy="777240"/>
+          </a:xfrm>
+          <a:prstGeom prst="rect">
+            <a:avLst/>
+          </a:prstGeom>
+        </p:spPr>
+      </p:pic>
     </p:spTree>
   </p:cSld>
   <p:clrMapOvr>
@@ -9838,6 +10054,30 @@
           </a:p>
         </p:txBody>
       </p:sp>
+      <p:pic>
+        <p:nvPicPr>
+          <p:cNvPr id="17" name="Picture 16" descr="UBO.jpeg"/>
+          <p:cNvPicPr>
+            <a:picLocks noChangeAspect="1"/>
+          </p:cNvPicPr>
+          <p:nvPr/>
+        </p:nvPicPr>
+        <p:blipFill>
+          <a:blip r:embed="rId12"/>
+          <a:stretch>
+            <a:fillRect/>
+          </a:stretch>
+        </p:blipFill>
+        <p:spPr>
+          <a:xfrm>
+            <a:off x="950000" y="950000"/>
+            <a:ext cx="777240" cy="777240"/>
+          </a:xfrm>
+          <a:prstGeom prst="rect">
+            <a:avLst/>
+          </a:prstGeom>
+        </p:spPr>
+      </p:pic>
     </p:spTree>
   </p:cSld>
   <p:clrMapOvr>
@@ -10449,6 +10689,30 @@
           </a:p>
         </p:txBody>
       </p:sp>
+      <p:pic>
+        <p:nvPicPr>
+          <p:cNvPr id="17" name="Picture 16" descr="UBO.jpeg"/>
+          <p:cNvPicPr>
+            <a:picLocks noChangeAspect="1"/>
+          </p:cNvPicPr>
+          <p:nvPr/>
+        </p:nvPicPr>
+        <p:blipFill>
+          <a:blip r:embed="rId12"/>
+          <a:stretch>
+            <a:fillRect/>
+          </a:stretch>
+        </p:blipFill>
+        <p:spPr>
+          <a:xfrm>
+            <a:off x="950000" y="950000"/>
+            <a:ext cx="777240" cy="777240"/>
+          </a:xfrm>
+          <a:prstGeom prst="rect">
+            <a:avLst/>
+          </a:prstGeom>
+        </p:spPr>
+      </p:pic>
     </p:spTree>
   </p:cSld>
   <p:clrMapOvr>
@@ -10929,6 +11193,30 @@
           </a:p>
         </p:txBody>
       </p:sp>
+      <p:pic>
+        <p:nvPicPr>
+          <p:cNvPr id="15" name="Picture 14" descr="UBO.jpeg"/>
+          <p:cNvPicPr>
+            <a:picLocks noChangeAspect="1"/>
+          </p:cNvPicPr>
+          <p:nvPr/>
+        </p:nvPicPr>
+        <p:blipFill>
+          <a:blip r:embed="rId10"/>
+          <a:stretch>
+            <a:fillRect/>
+          </a:stretch>
+        </p:blipFill>
+        <p:spPr>
+          <a:xfrm>
+            <a:off x="950000" y="950000"/>
+            <a:ext cx="777240" cy="777240"/>
+          </a:xfrm>
+          <a:prstGeom prst="rect">
+            <a:avLst/>
+          </a:prstGeom>
+        </p:spPr>
+      </p:pic>
     </p:spTree>
   </p:cSld>
   <p:clrMapOvr>
@@ -11394,6 +11682,30 @@
           </a:p>
         </p:txBody>
       </p:sp>
+      <p:pic>
+        <p:nvPicPr>
+          <p:cNvPr id="15" name="Picture 14" descr="UBO.jpeg"/>
+          <p:cNvPicPr>
+            <a:picLocks noChangeAspect="1"/>
+          </p:cNvPicPr>
+          <p:nvPr/>
+        </p:nvPicPr>
+        <p:blipFill>
+          <a:blip r:embed="rId10"/>
+          <a:stretch>
+            <a:fillRect/>
+          </a:stretch>
+        </p:blipFill>
+        <p:spPr>
+          <a:xfrm>
+            <a:off x="950000" y="950000"/>
+            <a:ext cx="777240" cy="777240"/>
+          </a:xfrm>
+          <a:prstGeom prst="rect">
+            <a:avLst/>
+          </a:prstGeom>
+        </p:spPr>
+      </p:pic>
     </p:spTree>
   </p:cSld>
   <p:clrMapOvr>

</xml_diff>